<commit_message>
feat(skill): 落地 Agent 原生 Skill 登记与洞察元 Skill 底座
- Agent 原生 Skill：全局 ts_agent_skill 草稿/发布/下线、登记台页面、工作台 / 调用与服务端核验注入的客群上下文
- 洞察元 Skill：分析三件套（事实/诊断/行动）+ 图表三件套（原子/意图/组合），源码在 skills/，结果契约为 insight-result 块
- 结果回流：Python 抽取 + Java 校验组装 skill_report，工作台复用洞察面板渲染卡片与图表
- 迁移：旧 tagpilot-insight 工程并入 tagpilot-agent（legacy），新增 V20260930_01 与技能种子 sql/seed/agent-meta-skills.sql
- 修复：技能轮次计数口径、启动脚本覆盖宿主 ANTHROPIC_*、技能失败日志、过期 e2e 定位符与测试夹具

Co-Authored-By: Claude Sonnet 5 <noreply@anthropic.com>
</commit_message>
<xml_diff>
--- a/docs/交付文档/智能体挑战赛路演PPT（标签智能体）-v2.0.pptx
+++ b/docs/交付文档/智能体挑战赛路演PPT（标签智能体）-v2.0.pptx
@@ -11445,7 +11445,7 @@
             <a:r>
               <a:rPr lang="en-US" altLang="zh-CN" sz="3000" b="1" dirty="0">
                 <a:solidFill>
-                  <a:srgbClr val="A87A10"/>
+                  <a:srgbClr val="C25A0E"/>
                 </a:solidFill>
                 <a:latin typeface="Cambria" pitchFamily="34" charset="0"/>
                 <a:ea typeface="Cambria" pitchFamily="34" charset="-122"/>
@@ -11455,7 +11455,7 @@
             </a:r>
             <a:endParaRPr lang="en-US" altLang="zh-CN" sz="3000" b="1" dirty="0">
               <a:solidFill>
-                <a:srgbClr val="A87A10"/>
+                <a:srgbClr val="C25A0E"/>
               </a:solidFill>
               <a:latin typeface="Cambria" pitchFamily="34" charset="0"/>
               <a:ea typeface="Cambria" pitchFamily="34" charset="-122"/>
@@ -12512,6 +12512,17 @@
               <a:buNone/>
             </a:pPr>
             <a:r>
+              <a:rPr lang="zh-CN" altLang="en-US" sz="2600" b="1" dirty="0">
+                <a:solidFill>
+                  <a:srgbClr val="2A1C0E"/>
+                </a:solidFill>
+                <a:latin typeface="微软雅黑" pitchFamily="34" charset="0"/>
+                <a:ea typeface="微软雅黑" pitchFamily="34" charset="-122"/>
+                <a:cs typeface="微软雅黑" pitchFamily="34" charset="-120"/>
+              </a:rPr>
+              <a:t>整体</a:t>
+            </a:r>
+            <a:r>
               <a:rPr lang="en-US" sz="2600" b="1" dirty="0">
                 <a:solidFill>
                   <a:srgbClr val="2A1C0E"/>
@@ -12520,15 +12531,98 @@
                 <a:ea typeface="微软雅黑" pitchFamily="34" charset="-122"/>
                 <a:cs typeface="微软雅黑" pitchFamily="34" charset="-120"/>
               </a:rPr>
-              <a:t>四层架构：Java 管权限，Python 管智能</a:t>
+              <a:t>架构：Java 管权限，Python 管智能</a:t>
             </a:r>
             <a:endParaRPr lang="en-US" sz="2600" dirty="0"/>
+          </a:p>
+        </p:txBody>
+      </p:sp>
+      <p:sp>
+        <p:nvSpPr>
+          <p:cNvPr id="5" name="Text 2"/>
+          <p:cNvSpPr/>
+          <p:nvPr/>
+        </p:nvSpPr>
+        <p:spPr>
+          <a:xfrm>
+            <a:off x="658495" y="6346190"/>
+            <a:ext cx="10143490" cy="413385"/>
+          </a:xfrm>
+          <a:prstGeom prst="rect">
+            <a:avLst/>
+          </a:prstGeom>
+          <a:noFill/>
+        </p:spPr>
+        <p:txBody>
+          <a:bodyPr wrap="square" lIns="0" tIns="0" rIns="0" bIns="0" rtlCol="0" anchor="t"/>
+          <a:lstStyle/>
+          <a:p>
+            <a:pPr marL="0" indent="0" algn="l">
+              <a:buNone/>
+            </a:pPr>
+            <a:r>
+              <a:rPr lang="zh-CN" altLang="en-US" sz="1600" dirty="0">
+                <a:solidFill>
+                  <a:srgbClr val="96897B"/>
+                </a:solidFill>
+                <a:latin typeface="微软雅黑" pitchFamily="34" charset="0"/>
+                <a:ea typeface="微软雅黑" pitchFamily="34" charset="-122"/>
+                <a:cs typeface="微软雅黑" pitchFamily="34" charset="-120"/>
+              </a:rPr>
+              <a:t>模型侧可替换，业务侧可审计：前沿能力独立成进程，关键环节留在成熟主干。</a:t>
+            </a:r>
+            <a:endParaRPr lang="zh-CN" altLang="en-US" sz="1600" dirty="0">
+              <a:solidFill>
+                <a:srgbClr val="96897B"/>
+              </a:solidFill>
+              <a:latin typeface="微软雅黑" pitchFamily="34" charset="0"/>
+              <a:ea typeface="微软雅黑" pitchFamily="34" charset="-122"/>
+              <a:cs typeface="微软雅黑" pitchFamily="34" charset="-120"/>
+            </a:endParaRPr>
+          </a:p>
+        </p:txBody>
+      </p:sp>
+      <p:sp>
+        <p:nvSpPr>
+          <p:cNvPr id="6" name="Text 3"/>
+          <p:cNvSpPr/>
+          <p:nvPr/>
+        </p:nvSpPr>
+        <p:spPr>
+          <a:xfrm>
+            <a:off x="10801807" y="6345936"/>
+            <a:ext cx="822960" cy="274320"/>
+          </a:xfrm>
+          <a:prstGeom prst="rect">
+            <a:avLst/>
+          </a:prstGeom>
+          <a:noFill/>
+        </p:spPr>
+        <p:txBody>
+          <a:bodyPr wrap="square" lIns="0" tIns="0" rIns="0" bIns="0" rtlCol="0" anchor="t"/>
+          <a:lstStyle/>
+          <a:p>
+            <a:pPr marL="0" indent="0" algn="r">
+              <a:buNone/>
+            </a:pPr>
+            <a:r>
+              <a:rPr lang="en-US" sz="900" dirty="0">
+                <a:solidFill>
+                  <a:srgbClr val="96897B"/>
+                </a:solidFill>
+                <a:latin typeface="Cambria" pitchFamily="34" charset="0"/>
+                <a:ea typeface="Cambria" pitchFamily="34" charset="-122"/>
+                <a:cs typeface="Cambria" pitchFamily="34" charset="-120"/>
+              </a:rPr>
+              <a:t>04</a:t>
+            </a:r>
+            <a:endParaRPr lang="en-US" sz="900" dirty="0"/>
           </a:p>
         </p:txBody>
       </p:sp>
       <p:pic>
         <p:nvPicPr>
-          <p:cNvPr id="4" name="Image 0" descr=".pptx-build/assets/arch-tagpilot.png"/>
+          <p:cNvPr id="8" name="图片 7"/>
           <p:cNvPicPr>
             <a:picLocks noChangeAspect="1"/>
           </p:cNvPicPr>
@@ -12542,90 +12636,14 @@
         </p:blipFill>
         <p:spPr>
           <a:xfrm>
-            <a:off x="566928" y="1243584"/>
-            <a:ext cx="11057839" cy="4809744"/>
+            <a:off x="1148715" y="1170305"/>
+            <a:ext cx="9162415" cy="5010785"/>
           </a:xfrm>
           <a:prstGeom prst="rect">
             <a:avLst/>
           </a:prstGeom>
         </p:spPr>
       </p:pic>
-      <p:sp>
-        <p:nvSpPr>
-          <p:cNvPr id="5" name="Text 2"/>
-          <p:cNvSpPr/>
-          <p:nvPr/>
-        </p:nvSpPr>
-        <p:spPr>
-          <a:xfrm>
-            <a:off x="566928" y="6345936"/>
-            <a:ext cx="10143439" cy="310896"/>
-          </a:xfrm>
-          <a:prstGeom prst="rect">
-            <a:avLst/>
-          </a:prstGeom>
-          <a:noFill/>
-        </p:spPr>
-        <p:txBody>
-          <a:bodyPr wrap="square" lIns="0" tIns="0" rIns="0" bIns="0" rtlCol="0" anchor="t"/>
-          <a:lstStyle/>
-          <a:p>
-            <a:pPr marL="0" indent="0" algn="l">
-              <a:buNone/>
-            </a:pPr>
-            <a:r>
-              <a:rPr lang="en-US" sz="850" dirty="0">
-                <a:solidFill>
-                  <a:srgbClr val="96897B"/>
-                </a:solidFill>
-                <a:latin typeface="微软雅黑" pitchFamily="34" charset="0"/>
-                <a:ea typeface="微软雅黑" pitchFamily="34" charset="-122"/>
-                <a:cs typeface="微软雅黑" pitchFamily="34" charset="-120"/>
-              </a:rPr>
-              <a:t>底座：MySQL 8（76 张表，ts_* 17 张）· Milvus 19530（BGE-M3 1024 维，3,374 文档）· Redis · 加密 SQLite。控制面持有身份、资格、发布版本、编译、统计、建群六项权威；资格在检索时重算、只收紧不放宽；浏览器从不直连 Python。来源：docs/architecture/标签语义引擎与Agent编排层.md；AGENTS.md（模块与依赖方向）。</a:t>
-            </a:r>
-            <a:endParaRPr lang="en-US" sz="850" dirty="0"/>
-          </a:p>
-        </p:txBody>
-      </p:sp>
-      <p:sp>
-        <p:nvSpPr>
-          <p:cNvPr id="6" name="Text 3"/>
-          <p:cNvSpPr/>
-          <p:nvPr/>
-        </p:nvSpPr>
-        <p:spPr>
-          <a:xfrm>
-            <a:off x="10801807" y="6345936"/>
-            <a:ext cx="822960" cy="274320"/>
-          </a:xfrm>
-          <a:prstGeom prst="rect">
-            <a:avLst/>
-          </a:prstGeom>
-          <a:noFill/>
-        </p:spPr>
-        <p:txBody>
-          <a:bodyPr wrap="square" lIns="0" tIns="0" rIns="0" bIns="0" rtlCol="0" anchor="t"/>
-          <a:lstStyle/>
-          <a:p>
-            <a:pPr marL="0" indent="0" algn="r">
-              <a:buNone/>
-            </a:pPr>
-            <a:r>
-              <a:rPr lang="en-US" sz="900" dirty="0">
-                <a:solidFill>
-                  <a:srgbClr val="96897B"/>
-                </a:solidFill>
-                <a:latin typeface="Cambria" pitchFamily="34" charset="0"/>
-                <a:ea typeface="Cambria" pitchFamily="34" charset="-122"/>
-                <a:cs typeface="Cambria" pitchFamily="34" charset="-120"/>
-              </a:rPr>
-              <a:t>04</a:t>
-            </a:r>
-            <a:endParaRPr lang="en-US" sz="900" dirty="0"/>
-          </a:p>
-        </p:txBody>
-      </p:sp>
     </p:spTree>
   </p:cSld>
   <p:clrMapOvr>
@@ -12639,9 +12657,7 @@
   <p:cSld>
     <p:bg>
       <p:bgPr>
-        <a:solidFill>
-          <a:srgbClr val="FFFFFF"/>
-        </a:solidFill>
+        <a:noFill/>
         <a:effectLst/>
       </p:bgPr>
     </p:bg>
@@ -12721,7 +12737,7 @@
               <a:buNone/>
             </a:pPr>
             <a:r>
-              <a:rPr lang="en-US" sz="2600" b="1" dirty="0">
+              <a:rPr lang="zh-CN" altLang="en-US" sz="2600" b="1" dirty="0">
                 <a:solidFill>
                   <a:srgbClr val="2A1C0E"/>
                 </a:solidFill>
@@ -12729,15 +12745,127 @@
                 <a:ea typeface="微软雅黑" pitchFamily="34" charset="-122"/>
                 <a:cs typeface="微软雅黑" pitchFamily="34" charset="-120"/>
               </a:rPr>
-              <a:t>五个节点，三条分支都有明确出口</a:t>
-            </a:r>
-            <a:endParaRPr lang="en-US" sz="2600" dirty="0"/>
+              <a:t>把 </a:t>
+            </a:r>
+            <a:r>
+              <a:rPr lang="en-US" altLang="zh-CN" sz="2600" b="1" dirty="0">
+                <a:solidFill>
+                  <a:srgbClr val="2A1C0E"/>
+                </a:solidFill>
+                <a:latin typeface="微软雅黑" pitchFamily="34" charset="0"/>
+                <a:ea typeface="微软雅黑" pitchFamily="34" charset="-122"/>
+                <a:cs typeface="微软雅黑" pitchFamily="34" charset="-120"/>
+              </a:rPr>
+              <a:t>Agent </a:t>
+            </a:r>
+            <a:r>
+              <a:rPr lang="zh-CN" altLang="en-US" sz="2600" b="1" dirty="0">
+                <a:solidFill>
+                  <a:srgbClr val="2A1C0E"/>
+                </a:solidFill>
+                <a:latin typeface="微软雅黑" pitchFamily="34" charset="0"/>
+                <a:ea typeface="微软雅黑" pitchFamily="34" charset="-122"/>
+                <a:cs typeface="微软雅黑" pitchFamily="34" charset="-120"/>
+              </a:rPr>
+              <a:t>放进“有边界”的流程里，每一步都可校验、可回退</a:t>
+            </a:r>
+            <a:endParaRPr lang="zh-CN" altLang="en-US" sz="2600" b="1" dirty="0">
+              <a:solidFill>
+                <a:srgbClr val="2A1C0E"/>
+              </a:solidFill>
+              <a:latin typeface="微软雅黑" pitchFamily="34" charset="0"/>
+              <a:ea typeface="微软雅黑" pitchFamily="34" charset="-122"/>
+              <a:cs typeface="微软雅黑" pitchFamily="34" charset="-120"/>
+            </a:endParaRPr>
+          </a:p>
+        </p:txBody>
+      </p:sp>
+      <p:sp>
+        <p:nvSpPr>
+          <p:cNvPr id="5" name="Text 2"/>
+          <p:cNvSpPr/>
+          <p:nvPr/>
+        </p:nvSpPr>
+        <p:spPr>
+          <a:xfrm>
+            <a:off x="566928" y="6345936"/>
+            <a:ext cx="10143439" cy="310896"/>
+          </a:xfrm>
+          <a:prstGeom prst="rect">
+            <a:avLst/>
+          </a:prstGeom>
+          <a:noFill/>
+        </p:spPr>
+        <p:txBody>
+          <a:bodyPr wrap="square" lIns="0" tIns="0" rIns="0" bIns="0" rtlCol="0" anchor="t"/>
+          <a:lstStyle/>
+          <a:p>
+            <a:pPr marL="0" indent="0" algn="l">
+              <a:buNone/>
+            </a:pPr>
+            <a:r>
+              <a:rPr lang="zh-CN" altLang="en-US" sz="1000" dirty="0">
+                <a:solidFill>
+                  <a:srgbClr val="96897B"/>
+                </a:solidFill>
+                <a:latin typeface="微软雅黑" pitchFamily="34" charset="0"/>
+                <a:ea typeface="微软雅黑" pitchFamily="34" charset="-122"/>
+                <a:cs typeface="微软雅黑" pitchFamily="34" charset="-120"/>
+              </a:rPr>
+              <a:t>用户一句话进入后，系统自动完成标签检索、条件编排与规则校验。遇到歧义或校验失败时，自动进入追问或修正，确保结果可核验、可追溯、可人工接管。</a:t>
+            </a:r>
+            <a:endParaRPr lang="zh-CN" altLang="en-US" sz="1000" dirty="0">
+              <a:solidFill>
+                <a:srgbClr val="96897B"/>
+              </a:solidFill>
+              <a:latin typeface="微软雅黑" pitchFamily="34" charset="0"/>
+              <a:ea typeface="微软雅黑" pitchFamily="34" charset="-122"/>
+              <a:cs typeface="微软雅黑" pitchFamily="34" charset="-120"/>
+            </a:endParaRPr>
+          </a:p>
+        </p:txBody>
+      </p:sp>
+      <p:sp>
+        <p:nvSpPr>
+          <p:cNvPr id="6" name="Text 3"/>
+          <p:cNvSpPr/>
+          <p:nvPr/>
+        </p:nvSpPr>
+        <p:spPr>
+          <a:xfrm>
+            <a:off x="10801807" y="6345936"/>
+            <a:ext cx="822960" cy="274320"/>
+          </a:xfrm>
+          <a:prstGeom prst="rect">
+            <a:avLst/>
+          </a:prstGeom>
+          <a:noFill/>
+        </p:spPr>
+        <p:txBody>
+          <a:bodyPr wrap="square" lIns="0" tIns="0" rIns="0" bIns="0" rtlCol="0" anchor="t"/>
+          <a:lstStyle/>
+          <a:p>
+            <a:pPr marL="0" indent="0" algn="r">
+              <a:buNone/>
+            </a:pPr>
+            <a:r>
+              <a:rPr lang="en-US" sz="900" dirty="0">
+                <a:solidFill>
+                  <a:srgbClr val="96897B"/>
+                </a:solidFill>
+                <a:latin typeface="Cambria" pitchFamily="34" charset="0"/>
+                <a:ea typeface="Cambria" pitchFamily="34" charset="-122"/>
+                <a:cs typeface="Cambria" pitchFamily="34" charset="-120"/>
+              </a:rPr>
+              <a:t>05</a:t>
+            </a:r>
+            <a:endParaRPr lang="en-US" sz="900" dirty="0"/>
           </a:p>
         </p:txBody>
       </p:sp>
       <p:pic>
         <p:nvPicPr>
-          <p:cNvPr id="4" name="Image 0" descr=".pptx-build/assets/flow-tagpilot.png"/>
+          <p:cNvPr id="8" name="图片 7"/>
           <p:cNvPicPr>
             <a:picLocks noChangeAspect="1"/>
           </p:cNvPicPr>
@@ -12751,90 +12879,14 @@
         </p:blipFill>
         <p:spPr>
           <a:xfrm>
-            <a:off x="1590033" y="1280160"/>
-            <a:ext cx="9011630" cy="4754880"/>
+            <a:off x="1409065" y="1170305"/>
+            <a:ext cx="8459470" cy="5081905"/>
           </a:xfrm>
           <a:prstGeom prst="rect">
             <a:avLst/>
           </a:prstGeom>
         </p:spPr>
       </p:pic>
-      <p:sp>
-        <p:nvSpPr>
-          <p:cNvPr id="5" name="Text 2"/>
-          <p:cNvSpPr/>
-          <p:nvPr/>
-        </p:nvSpPr>
-        <p:spPr>
-          <a:xfrm>
-            <a:off x="566928" y="6345936"/>
-            <a:ext cx="10143439" cy="310896"/>
-          </a:xfrm>
-          <a:prstGeom prst="rect">
-            <a:avLst/>
-          </a:prstGeom>
-          <a:noFill/>
-        </p:spPr>
-        <p:txBody>
-          <a:bodyPr wrap="square" lIns="0" tIns="0" rIns="0" bIns="0" rtlCol="0" anchor="t"/>
-          <a:lstStyle/>
-          <a:p>
-            <a:pPr marL="0" indent="0" algn="l">
-              <a:buNone/>
-            </a:pPr>
-            <a:r>
-              <a:rPr lang="en-US" sz="850" dirty="0">
-                <a:solidFill>
-                  <a:srgbClr val="96897B"/>
-                </a:solidFill>
-                <a:latin typeface="微软雅黑" pitchFamily="34" charset="0"/>
-                <a:ea typeface="微软雅黑" pitchFamily="34" charset="-122"/>
-                <a:cs typeface="微软雅黑" pitchFamily="34" charset="-120"/>
-              </a:rPr>
-              <a:t>三条分支都不产出生效条件、都不能统计或建群：L2 只保留可核验条件，L3 只有候选建议，L4 可重试；预算耗尽的降级绝不宣称「业务上没有这个标签」。同 ID + 同原文幂等；Guard 为纯 Python，不依赖 SDK，手工编辑也走同一套校验。来源：tagpilot-agent/README.md（工具集、预算与 L2/L3/L4 降级）；tagpilot_agent/guards/plan_validator.py。</a:t>
-            </a:r>
-            <a:endParaRPr lang="en-US" sz="850" dirty="0"/>
-          </a:p>
-        </p:txBody>
-      </p:sp>
-      <p:sp>
-        <p:nvSpPr>
-          <p:cNvPr id="6" name="Text 3"/>
-          <p:cNvSpPr/>
-          <p:nvPr/>
-        </p:nvSpPr>
-        <p:spPr>
-          <a:xfrm>
-            <a:off x="10801807" y="6345936"/>
-            <a:ext cx="822960" cy="274320"/>
-          </a:xfrm>
-          <a:prstGeom prst="rect">
-            <a:avLst/>
-          </a:prstGeom>
-          <a:noFill/>
-        </p:spPr>
-        <p:txBody>
-          <a:bodyPr wrap="square" lIns="0" tIns="0" rIns="0" bIns="0" rtlCol="0" anchor="t"/>
-          <a:lstStyle/>
-          <a:p>
-            <a:pPr marL="0" indent="0" algn="r">
-              <a:buNone/>
-            </a:pPr>
-            <a:r>
-              <a:rPr lang="en-US" sz="900" dirty="0">
-                <a:solidFill>
-                  <a:srgbClr val="96897B"/>
-                </a:solidFill>
-                <a:latin typeface="Cambria" pitchFamily="34" charset="0"/>
-                <a:ea typeface="Cambria" pitchFamily="34" charset="-122"/>
-                <a:cs typeface="Cambria" pitchFamily="34" charset="-120"/>
-              </a:rPr>
-              <a:t>05</a:t>
-            </a:r>
-            <a:endParaRPr lang="en-US" sz="900" dirty="0"/>
-          </a:p>
-        </p:txBody>
-      </p:sp>
     </p:spTree>
   </p:cSld>
   <p:clrMapOvr>
@@ -12923,24 +12975,24 @@
           <a:noFill/>
         </p:spPr>
         <p:txBody>
-          <a:bodyPr wrap="square" lIns="0" tIns="0" rIns="0" bIns="0" rtlCol="0" anchor="ctr"/>
-          <a:lstStyle/>
-          <a:p>
-            <a:pPr marL="0" indent="0" algn="l">
-              <a:buNone/>
-            </a:pPr>
-            <a:r>
-              <a:rPr lang="en-US" sz="2600" b="1" dirty="0">
+          <a:bodyPr wrap="square" lIns="0" tIns="0" rIns="0" bIns="0" anchor="ctr"/>
+          <a:lstStyle/>
+          <a:p>
+            <a:pPr marL="0" indent="0" algn="l">
+              <a:buNone/>
+            </a:pPr>
+            <a:r>
+              <a:rPr sz="2600" b="1">
                 <a:solidFill>
                   <a:srgbClr val="2A1C0E"/>
                 </a:solidFill>
-                <a:latin typeface="微软雅黑" pitchFamily="34" charset="0"/>
-                <a:ea typeface="微软雅黑" pitchFamily="34" charset="-122"/>
-                <a:cs typeface="微软雅黑" pitchFamily="34" charset="-120"/>
-              </a:rPr>
-              <a:t>三个模块，三个真难点</a:t>
-            </a:r>
-            <a:endParaRPr lang="en-US" sz="2600" dirty="0"/>
+                <a:latin typeface="微软雅黑"/>
+                <a:ea typeface="微软雅黑"/>
+                <a:cs typeface="微软雅黑"/>
+              </a:rPr>
+              <a:t>三个核心模块，解决三类技术难点</a:t>
+            </a:r>
+            <a:endParaRPr sz="2600"/>
           </a:p>
         </p:txBody>
       </p:sp>
@@ -13094,24 +13146,24 @@
           <a:noFill/>
         </p:spPr>
         <p:txBody>
-          <a:bodyPr wrap="square" lIns="0" tIns="0" rIns="0" bIns="0" rtlCol="0" anchor="t"/>
-          <a:lstStyle/>
-          <a:p>
-            <a:pPr marL="0" indent="0" algn="l">
-              <a:buNone/>
-            </a:pPr>
-            <a:r>
-              <a:rPr lang="en-US" sz="880" b="1" dirty="0">
+          <a:bodyPr wrap="square" lIns="0" tIns="0" rIns="0" bIns="0" anchor="t"/>
+          <a:lstStyle/>
+          <a:p>
+            <a:pPr marL="0" indent="0" algn="l">
+              <a:buNone/>
+            </a:pPr>
+            <a:r>
+              <a:rPr sz="880" b="1">
                 <a:solidFill>
                   <a:srgbClr val="A87A10"/>
                 </a:solidFill>
-                <a:latin typeface="微软雅黑" pitchFamily="34" charset="0"/>
-                <a:ea typeface="微软雅黑" pitchFamily="34" charset="-122"/>
-                <a:cs typeface="微软雅黑" pitchFamily="34" charset="-120"/>
-              </a:rPr>
-              <a:t>难点</a:t>
-            </a:r>
-            <a:endParaRPr lang="en-US" sz="880" dirty="0"/>
+                <a:latin typeface="微软雅黑"/>
+                <a:ea typeface="微软雅黑"/>
+                <a:cs typeface="微软雅黑"/>
+              </a:rPr>
+              <a:t>做什么</a:t>
+            </a:r>
+            <a:endParaRPr sz="880"/>
           </a:p>
         </p:txBody>
       </p:sp>
@@ -13123,36 +13175,60 @@
         </p:nvSpPr>
         <p:spPr>
           <a:xfrm>
-            <a:off x="768096" y="2377440"/>
-            <a:ext cx="3161690" cy="786384"/>
-          </a:xfrm>
-          <a:prstGeom prst="rect">
-            <a:avLst/>
-          </a:prstGeom>
-          <a:noFill/>
-        </p:spPr>
-        <p:txBody>
-          <a:bodyPr wrap="square" lIns="0" tIns="0" rIns="0" bIns="0" rtlCol="0" anchor="t"/>
+            <a:off x="768096" y="2390775"/>
+            <a:ext cx="3161690" cy="495300"/>
+          </a:xfrm>
+          <a:prstGeom prst="rect">
+            <a:avLst/>
+          </a:prstGeom>
+          <a:noFill/>
+        </p:spPr>
+        <p:txBody>
+          <a:bodyPr wrap="square" lIns="0" tIns="0" rIns="0" bIns="0" anchor="t">
+            <a:noAutofit/>
+          </a:bodyPr>
           <a:lstStyle/>
           <a:p>
             <a:pPr marL="0" indent="0" algn="l">
               <a:lnSpc>
-                <a:spcPts val="2300"/>
+                <a:spcPct val="120000"/>
               </a:lnSpc>
               <a:buNone/>
-            </a:pPr>
-            <a:r>
-              <a:rPr lang="en-US" sz="1700" b="1" dirty="0">
+              <a:defRPr sz="1200" b="0"/>
+            </a:pPr>
+            <a:r>
+              <a:rPr sz="1200" b="0">
                 <a:solidFill>
                   <a:srgbClr val="2A1C0E"/>
                 </a:solidFill>
-                <a:latin typeface="微软雅黑" pitchFamily="34" charset="0"/>
-                <a:ea typeface="微软雅黑" pitchFamily="34" charset="-122"/>
-                <a:cs typeface="微软雅黑" pitchFamily="34" charset="-120"/>
-              </a:rPr>
-              <a:t>口径不能近似</a:t>
-            </a:r>
-            <a:endParaRPr lang="en-US" sz="1700" dirty="0"/>
+                <a:latin typeface="微软雅黑"/>
+                <a:ea typeface="微软雅黑"/>
+                <a:cs typeface="微软雅黑"/>
+              </a:rPr>
+              <a:t>将自然语言需求匹配到业务标签，</a:t>
+            </a:r>
+            <a:endParaRPr sz="1700"/>
+          </a:p>
+          <a:p>
+            <a:pPr marL="0" indent="0" algn="l">
+              <a:lnSpc>
+                <a:spcPct val="120000"/>
+              </a:lnSpc>
+              <a:buNone/>
+              <a:defRPr sz="1200" b="0"/>
+            </a:pPr>
+            <a:r>
+              <a:rPr sz="1200" b="0">
+                <a:solidFill>
+                  <a:srgbClr val="2A1C0E"/>
+                </a:solidFill>
+                <a:latin typeface="微软雅黑"/>
+                <a:ea typeface="微软雅黑"/>
+                <a:cs typeface="微软雅黑"/>
+              </a:rPr>
+              <a:t>确保筛选口径准确。</a:t>
+            </a:r>
+            <a:endParaRPr sz="1700"/>
           </a:p>
         </p:txBody>
       </p:sp>
@@ -13164,7 +13240,7 @@
         </p:nvSpPr>
         <p:spPr>
           <a:xfrm>
-            <a:off x="768096" y="3310128"/>
+            <a:off x="768096" y="2981325"/>
             <a:ext cx="3161690" cy="182880"/>
           </a:xfrm>
           <a:prstGeom prst="rect">
@@ -13173,24 +13249,24 @@
           <a:noFill/>
         </p:spPr>
         <p:txBody>
-          <a:bodyPr wrap="square" lIns="0" tIns="0" rIns="0" bIns="0" rtlCol="0" anchor="t"/>
-          <a:lstStyle/>
-          <a:p>
-            <a:pPr marL="0" indent="0" algn="l">
-              <a:buNone/>
-            </a:pPr>
-            <a:r>
-              <a:rPr lang="en-US" sz="880" b="1" dirty="0">
+          <a:bodyPr wrap="square" lIns="0" tIns="0" rIns="0" bIns="0" anchor="t"/>
+          <a:lstStyle/>
+          <a:p>
+            <a:pPr marL="0" indent="0" algn="l">
+              <a:buNone/>
+            </a:pPr>
+            <a:r>
+              <a:rPr sz="880" b="1">
                 <a:solidFill>
                   <a:srgbClr val="A87A10"/>
                 </a:solidFill>
-                <a:latin typeface="微软雅黑" pitchFamily="34" charset="0"/>
-                <a:ea typeface="微软雅黑" pitchFamily="34" charset="-122"/>
-                <a:cs typeface="微软雅黑" pitchFamily="34" charset="-120"/>
-              </a:rPr>
-              <a:t>解法</a:t>
-            </a:r>
-            <a:endParaRPr lang="en-US" sz="880" dirty="0"/>
+                <a:latin typeface="微软雅黑"/>
+                <a:ea typeface="微软雅黑"/>
+                <a:cs typeface="微软雅黑"/>
+              </a:rPr>
+              <a:t>用什么技术</a:t>
+            </a:r>
+            <a:endParaRPr sz="880"/>
           </a:p>
         </p:txBody>
       </p:sp>
@@ -13202,8 +13278,8 @@
         </p:nvSpPr>
         <p:spPr>
           <a:xfrm>
-            <a:off x="768096" y="3529584"/>
-            <a:ext cx="3161690" cy="2103120"/>
+            <a:off x="768096" y="3209925"/>
+            <a:ext cx="3161690" cy="2422779"/>
           </a:xfrm>
           <a:prstGeom prst="roundRect">
             <a:avLst>
@@ -13229,36 +13305,120 @@
         </p:nvSpPr>
         <p:spPr>
           <a:xfrm>
-            <a:off x="896112" y="3675888"/>
-            <a:ext cx="2905658" cy="1828800"/>
-          </a:xfrm>
-          <a:prstGeom prst="rect">
-            <a:avLst/>
-          </a:prstGeom>
-          <a:noFill/>
-        </p:spPr>
-        <p:txBody>
-          <a:bodyPr wrap="square" lIns="0" tIns="0" rIns="0" bIns="0" rtlCol="0" anchor="t"/>
-          <a:lstStyle/>
-          <a:p>
-            <a:pPr marL="0" indent="0" algn="l">
-              <a:lnSpc>
-                <a:spcPts val="1800"/>
-              </a:lnSpc>
-              <a:buNone/>
-            </a:pPr>
-            <a:r>
-              <a:rPr lang="en-US" sz="1200" dirty="0">
-                <a:solidFill>
-                  <a:srgbClr val="2A1C0E"/>
-                </a:solidFill>
-                <a:latin typeface="微软雅黑" pitchFamily="34" charset="0"/>
-                <a:ea typeface="微软雅黑" pitchFamily="34" charset="-122"/>
-                <a:cs typeface="微软雅黑" pitchFamily="34" charset="-120"/>
-              </a:rPr>
-              <a:t>跨桶阈值只有桶并集严格等于请求区间才可表达，否则返回 INEXPRESSIBLE ——「超过 100 万」不许近似成「100 万及以上」。</a:t>
-            </a:r>
-            <a:endParaRPr lang="en-US" sz="1200" dirty="0"/>
+            <a:off x="896112" y="3343275"/>
+            <a:ext cx="2905658" cy="2162175"/>
+          </a:xfrm>
+          <a:prstGeom prst="rect">
+            <a:avLst/>
+          </a:prstGeom>
+          <a:noFill/>
+        </p:spPr>
+        <p:txBody>
+          <a:bodyPr wrap="square" lIns="0" tIns="0" rIns="0" bIns="0" anchor="t">
+            <a:noAutofit/>
+          </a:bodyPr>
+          <a:lstStyle/>
+          <a:p>
+            <a:pPr>
+              <a:spcAft>
+                <a:spcPts val="700"/>
+              </a:spcAft>
+              <a:defRPr sz="1200" b="0">
+                <a:solidFill>
+                  <a:srgbClr val="2C2115"/>
+                </a:solidFill>
+                <a:latin typeface="微软雅黑"/>
+                <a:ea typeface="微软雅黑"/>
+                <a:cs typeface="微软雅黑"/>
+              </a:defRPr>
+            </a:pPr>
+            <a:r>
+              <a:t>语义检索（BGE-M3）理解用户表达，关键词匹配补充查找，再把更准确的标签排在前面。</a:t>
+            </a:r>
+          </a:p>
+          <a:p>
+            <a:pPr>
+              <a:spcAft>
+                <a:spcPts val="250"/>
+              </a:spcAft>
+              <a:defRPr sz="1200" b="0">
+                <a:solidFill>
+                  <a:srgbClr val="2C2115"/>
+                </a:solidFill>
+                <a:latin typeface="微软雅黑"/>
+                <a:ea typeface="微软雅黑"/>
+                <a:cs typeface="微软雅黑"/>
+              </a:defRPr>
+            </a:pPr>
+            <a:r>
+              <a:rPr b="1">
+                <a:solidFill>
+                  <a:srgbClr val="B77B00"/>
+                </a:solidFill>
+              </a:rPr>
+              <a:t>关键实现</a:t>
+            </a:r>
+            <a:endParaRPr b="1">
+              <a:solidFill>
+                <a:srgbClr val="B77B00"/>
+              </a:solidFill>
+            </a:endParaRPr>
+          </a:p>
+          <a:p>
+            <a:pPr>
+              <a:spcAft>
+                <a:spcPts val="300"/>
+              </a:spcAft>
+              <a:defRPr sz="1200" b="0">
+                <a:solidFill>
+                  <a:srgbClr val="2C2115"/>
+                </a:solidFill>
+                <a:latin typeface="微软雅黑"/>
+                <a:ea typeface="微软雅黑"/>
+                <a:cs typeface="微软雅黑"/>
+              </a:defRPr>
+            </a:pPr>
+            <a:r>
+              <a:rPr b="1"/>
+              <a:t>难点：语义相近，口径未必一致</a:t>
+            </a:r>
+            <a:endParaRPr b="1"/>
+          </a:p>
+          <a:p>
+            <a:pPr>
+              <a:spcAft>
+                <a:spcPts val="300"/>
+              </a:spcAft>
+              <a:defRPr sz="1200" b="0">
+                <a:solidFill>
+                  <a:srgbClr val="2C2115"/>
+                </a:solidFill>
+                <a:latin typeface="微软雅黑"/>
+                <a:ea typeface="微软雅黑"/>
+                <a:cs typeface="微软雅黑"/>
+              </a:defRPr>
+            </a:pPr>
+            <a:r>
+              <a:t>区间校验确保标签精确表达需求。跨桶并集必须严格等于目标区间，否则返回无法表达。</a:t>
+            </a:r>
+          </a:p>
+          <a:p>
+            <a:pPr>
+              <a:spcAft>
+                <a:spcPts val="300"/>
+              </a:spcAft>
+              <a:defRPr sz="1200" b="0">
+                <a:solidFill>
+                  <a:srgbClr val="2C2115"/>
+                </a:solidFill>
+                <a:latin typeface="微软雅黑"/>
+                <a:ea typeface="微软雅黑"/>
+                <a:cs typeface="微软雅黑"/>
+              </a:defRPr>
+            </a:pPr>
+            <a:r>
+              <a:t>例如：“超过 100 万”不能替换为“100 万及以上”。</a:t>
+            </a:r>
           </a:p>
         </p:txBody>
       </p:sp>
@@ -13412,24 +13572,24 @@
           <a:noFill/>
         </p:spPr>
         <p:txBody>
-          <a:bodyPr wrap="square" lIns="0" tIns="0" rIns="0" bIns="0" rtlCol="0" anchor="t"/>
-          <a:lstStyle/>
-          <a:p>
-            <a:pPr marL="0" indent="0" algn="l">
-              <a:buNone/>
-            </a:pPr>
-            <a:r>
-              <a:rPr lang="en-US" sz="880" b="1" dirty="0">
+          <a:bodyPr wrap="square" lIns="0" tIns="0" rIns="0" bIns="0" anchor="t"/>
+          <a:lstStyle/>
+          <a:p>
+            <a:pPr marL="0" indent="0" algn="l">
+              <a:buNone/>
+            </a:pPr>
+            <a:r>
+              <a:rPr sz="880" b="1">
                 <a:solidFill>
                   <a:srgbClr val="A87A10"/>
                 </a:solidFill>
-                <a:latin typeface="微软雅黑" pitchFamily="34" charset="0"/>
-                <a:ea typeface="微软雅黑" pitchFamily="34" charset="-122"/>
-                <a:cs typeface="微软雅黑" pitchFamily="34" charset="-120"/>
-              </a:rPr>
-              <a:t>难点</a:t>
-            </a:r>
-            <a:endParaRPr lang="en-US" sz="880" dirty="0"/>
+                <a:latin typeface="微软雅黑"/>
+                <a:ea typeface="微软雅黑"/>
+                <a:cs typeface="微软雅黑"/>
+              </a:rPr>
+              <a:t>做什么</a:t>
+            </a:r>
+            <a:endParaRPr sz="880"/>
           </a:p>
         </p:txBody>
       </p:sp>
@@ -13441,36 +13601,60 @@
         </p:nvSpPr>
         <p:spPr>
           <a:xfrm>
-            <a:off x="4515002" y="2377440"/>
-            <a:ext cx="3161690" cy="786384"/>
-          </a:xfrm>
-          <a:prstGeom prst="rect">
-            <a:avLst/>
-          </a:prstGeom>
-          <a:noFill/>
-        </p:spPr>
-        <p:txBody>
-          <a:bodyPr wrap="square" lIns="0" tIns="0" rIns="0" bIns="0" rtlCol="0" anchor="t"/>
+            <a:off x="4515002" y="2390775"/>
+            <a:ext cx="3161690" cy="495300"/>
+          </a:xfrm>
+          <a:prstGeom prst="rect">
+            <a:avLst/>
+          </a:prstGeom>
+          <a:noFill/>
+        </p:spPr>
+        <p:txBody>
+          <a:bodyPr wrap="square" lIns="0" tIns="0" rIns="0" bIns="0" anchor="t">
+            <a:noAutofit/>
+          </a:bodyPr>
           <a:lstStyle/>
           <a:p>
             <a:pPr marL="0" indent="0" algn="l">
               <a:lnSpc>
-                <a:spcPts val="2300"/>
+                <a:spcPct val="120000"/>
               </a:lnSpc>
               <a:buNone/>
-            </a:pPr>
-            <a:r>
-              <a:rPr lang="en-US" sz="1700" b="1" dirty="0">
+              <a:defRPr sz="1200" b="0"/>
+            </a:pPr>
+            <a:r>
+              <a:rPr sz="1200" b="0">
                 <a:solidFill>
                   <a:srgbClr val="2A1C0E"/>
                 </a:solidFill>
-                <a:latin typeface="微软雅黑" pitchFamily="34" charset="0"/>
-                <a:ea typeface="微软雅黑" pitchFamily="34" charset="-122"/>
-                <a:cs typeface="微软雅黑" pitchFamily="34" charset="-120"/>
-              </a:rPr>
-              <a:t>模型会「编」，权限不能编</a:t>
-            </a:r>
-            <a:endParaRPr lang="en-US" sz="1700" dirty="0"/>
+                <a:latin typeface="微软雅黑"/>
+                <a:ea typeface="微软雅黑"/>
+                <a:cs typeface="微软雅黑"/>
+              </a:rPr>
+              <a:t>将用户需求转化为客群圈选方案，</a:t>
+            </a:r>
+            <a:endParaRPr sz="1700"/>
+          </a:p>
+          <a:p>
+            <a:pPr marL="0" indent="0" algn="l">
+              <a:lnSpc>
+                <a:spcPct val="120000"/>
+              </a:lnSpc>
+              <a:buNone/>
+              <a:defRPr sz="1200" b="0"/>
+            </a:pPr>
+            <a:r>
+              <a:rPr sz="1200" b="0">
+                <a:solidFill>
+                  <a:srgbClr val="2A1C0E"/>
+                </a:solidFill>
+                <a:latin typeface="微软雅黑"/>
+                <a:ea typeface="微软雅黑"/>
+                <a:cs typeface="微软雅黑"/>
+              </a:rPr>
+              <a:t>支持校验、确认和执行。</a:t>
+            </a:r>
+            <a:endParaRPr sz="1700"/>
           </a:p>
         </p:txBody>
       </p:sp>
@@ -13482,7 +13666,7 @@
         </p:nvSpPr>
         <p:spPr>
           <a:xfrm>
-            <a:off x="4515002" y="3310128"/>
+            <a:off x="4515002" y="2981325"/>
             <a:ext cx="3161690" cy="182880"/>
           </a:xfrm>
           <a:prstGeom prst="rect">
@@ -13491,24 +13675,24 @@
           <a:noFill/>
         </p:spPr>
         <p:txBody>
-          <a:bodyPr wrap="square" lIns="0" tIns="0" rIns="0" bIns="0" rtlCol="0" anchor="t"/>
-          <a:lstStyle/>
-          <a:p>
-            <a:pPr marL="0" indent="0" algn="l">
-              <a:buNone/>
-            </a:pPr>
-            <a:r>
-              <a:rPr lang="en-US" sz="880" b="1" dirty="0">
+          <a:bodyPr wrap="square" lIns="0" tIns="0" rIns="0" bIns="0" anchor="t"/>
+          <a:lstStyle/>
+          <a:p>
+            <a:pPr marL="0" indent="0" algn="l">
+              <a:buNone/>
+            </a:pPr>
+            <a:r>
+              <a:rPr sz="880" b="1">
                 <a:solidFill>
                   <a:srgbClr val="A87A10"/>
                 </a:solidFill>
-                <a:latin typeface="微软雅黑" pitchFamily="34" charset="0"/>
-                <a:ea typeface="微软雅黑" pitchFamily="34" charset="-122"/>
-                <a:cs typeface="微软雅黑" pitchFamily="34" charset="-120"/>
-              </a:rPr>
-              <a:t>解法</a:t>
-            </a:r>
-            <a:endParaRPr lang="en-US" sz="880" dirty="0"/>
+                <a:latin typeface="微软雅黑"/>
+                <a:ea typeface="微软雅黑"/>
+                <a:cs typeface="微软雅黑"/>
+              </a:rPr>
+              <a:t>用什么技术</a:t>
+            </a:r>
+            <a:endParaRPr sz="880"/>
           </a:p>
         </p:txBody>
       </p:sp>
@@ -13520,8 +13704,8 @@
         </p:nvSpPr>
         <p:spPr>
           <a:xfrm>
-            <a:off x="4515002" y="3529584"/>
-            <a:ext cx="3161690" cy="2103120"/>
+            <a:off x="4515002" y="3209925"/>
+            <a:ext cx="3161690" cy="2422779"/>
           </a:xfrm>
           <a:prstGeom prst="roundRect">
             <a:avLst>
@@ -13547,36 +13731,120 @@
         </p:nvSpPr>
         <p:spPr>
           <a:xfrm>
-            <a:off x="4643018" y="3675888"/>
-            <a:ext cx="2905658" cy="1828800"/>
-          </a:xfrm>
-          <a:prstGeom prst="rect">
-            <a:avLst/>
-          </a:prstGeom>
-          <a:noFill/>
-        </p:spPr>
-        <p:txBody>
-          <a:bodyPr wrap="square" lIns="0" tIns="0" rIns="0" bIns="0" rtlCol="0" anchor="t"/>
-          <a:lstStyle/>
-          <a:p>
-            <a:pPr marL="0" indent="0" algn="l">
-              <a:lnSpc>
-                <a:spcPts val="1800"/>
-              </a:lnSpc>
-              <a:buNone/>
-            </a:pPr>
-            <a:r>
-              <a:rPr lang="en-US" sz="1200" dirty="0">
-                <a:solidFill>
-                  <a:srgbClr val="2A1C0E"/>
-                </a:solidFill>
-                <a:latin typeface="微软雅黑" pitchFamily="34" charset="0"/>
-                <a:ea typeface="微软雅黑" pitchFamily="34" charset="-122"/>
-                <a:cs typeface="微软雅黑" pitchFamily="34" charset="-120"/>
-              </a:rPr>
-              <a:t>Guard 与 SDK 完全解耦：工具调用、终态提交、手工编辑三条路径共用同一套校验；已冻结条件不可被续跑改动。</a:t>
-            </a:r>
-            <a:endParaRPr lang="en-US" sz="1200" dirty="0"/>
+            <a:off x="4643018" y="3343275"/>
+            <a:ext cx="2905658" cy="2162175"/>
+          </a:xfrm>
+          <a:prstGeom prst="rect">
+            <a:avLst/>
+          </a:prstGeom>
+          <a:noFill/>
+        </p:spPr>
+        <p:txBody>
+          <a:bodyPr wrap="square" lIns="0" tIns="0" rIns="0" bIns="0" anchor="t">
+            <a:noAutofit/>
+          </a:bodyPr>
+          <a:lstStyle/>
+          <a:p>
+            <a:pPr>
+              <a:spcAft>
+                <a:spcPts val="700"/>
+              </a:spcAft>
+              <a:defRPr sz="1200" b="0">
+                <a:solidFill>
+                  <a:srgbClr val="2C2115"/>
+                </a:solidFill>
+                <a:latin typeface="微软雅黑"/>
+                <a:ea typeface="微软雅黑"/>
+                <a:cs typeface="微软雅黑"/>
+              </a:defRPr>
+            </a:pPr>
+            <a:r>
+              <a:t>Claude Agent SDK 理解需求、调用工具，独立校验层检查方案和权限。</a:t>
+            </a:r>
+          </a:p>
+          <a:p>
+            <a:pPr>
+              <a:spcAft>
+                <a:spcPts val="250"/>
+              </a:spcAft>
+              <a:defRPr sz="1200" b="0">
+                <a:solidFill>
+                  <a:srgbClr val="2C2115"/>
+                </a:solidFill>
+                <a:latin typeface="微软雅黑"/>
+                <a:ea typeface="微软雅黑"/>
+                <a:cs typeface="微软雅黑"/>
+              </a:defRPr>
+            </a:pPr>
+            <a:r>
+              <a:rPr b="1">
+                <a:solidFill>
+                  <a:srgbClr val="B77B00"/>
+                </a:solidFill>
+              </a:rPr>
+              <a:t>关键实现</a:t>
+            </a:r>
+            <a:endParaRPr b="1">
+              <a:solidFill>
+                <a:srgbClr val="B77B00"/>
+              </a:solidFill>
+            </a:endParaRPr>
+          </a:p>
+          <a:p>
+            <a:pPr>
+              <a:spcAft>
+                <a:spcPts val="300"/>
+              </a:spcAft>
+              <a:defRPr sz="1200" b="0">
+                <a:solidFill>
+                  <a:srgbClr val="2C2115"/>
+                </a:solidFill>
+                <a:latin typeface="微软雅黑"/>
+                <a:ea typeface="微软雅黑"/>
+                <a:cs typeface="微软雅黑"/>
+              </a:defRPr>
+            </a:pPr>
+            <a:r>
+              <a:rPr b="1"/>
+              <a:t>难点：生成方案可能出错或越权</a:t>
+            </a:r>
+            <a:endParaRPr b="1"/>
+          </a:p>
+          <a:p>
+            <a:pPr>
+              <a:spcAft>
+                <a:spcPts val="300"/>
+              </a:spcAft>
+              <a:defRPr sz="1200" b="0">
+                <a:solidFill>
+                  <a:srgbClr val="2C2115"/>
+                </a:solidFill>
+                <a:latin typeface="微软雅黑"/>
+                <a:ea typeface="微软雅黑"/>
+                <a:cs typeface="微软雅黑"/>
+              </a:defRPr>
+            </a:pPr>
+            <a:r>
+              <a:t>工具调用、最终提交、手工编辑共用同一套校验规则，防止不同入口绕过约束。</a:t>
+            </a:r>
+          </a:p>
+          <a:p>
+            <a:pPr>
+              <a:spcAft>
+                <a:spcPts val="300"/>
+              </a:spcAft>
+              <a:defRPr sz="1200" b="0">
+                <a:solidFill>
+                  <a:srgbClr val="2C2115"/>
+                </a:solidFill>
+                <a:latin typeface="微软雅黑"/>
+                <a:ea typeface="微软雅黑"/>
+                <a:cs typeface="微软雅黑"/>
+              </a:defRPr>
+            </a:pPr>
+            <a:r>
+              <a:t>已冻结条件在后续对话中保持不变。方案通过校验后，才能进入相应执行环节。</a:t>
+            </a:r>
           </a:p>
         </p:txBody>
       </p:sp>
@@ -13730,24 +13998,24 @@
           <a:noFill/>
         </p:spPr>
         <p:txBody>
-          <a:bodyPr wrap="square" lIns="0" tIns="0" rIns="0" bIns="0" rtlCol="0" anchor="t"/>
-          <a:lstStyle/>
-          <a:p>
-            <a:pPr marL="0" indent="0" algn="l">
-              <a:buNone/>
-            </a:pPr>
-            <a:r>
-              <a:rPr lang="en-US" sz="880" b="1" dirty="0">
+          <a:bodyPr wrap="square" lIns="0" tIns="0" rIns="0" bIns="0" anchor="t"/>
+          <a:lstStyle/>
+          <a:p>
+            <a:pPr marL="0" indent="0" algn="l">
+              <a:buNone/>
+            </a:pPr>
+            <a:r>
+              <a:rPr sz="880" b="1">
                 <a:solidFill>
                   <a:srgbClr val="A87A10"/>
                 </a:solidFill>
-                <a:latin typeface="微软雅黑" pitchFamily="34" charset="0"/>
-                <a:ea typeface="微软雅黑" pitchFamily="34" charset="-122"/>
-                <a:cs typeface="微软雅黑" pitchFamily="34" charset="-120"/>
-              </a:rPr>
-              <a:t>难点</a:t>
-            </a:r>
-            <a:endParaRPr lang="en-US" sz="880" dirty="0"/>
+                <a:latin typeface="微软雅黑"/>
+                <a:ea typeface="微软雅黑"/>
+                <a:cs typeface="微软雅黑"/>
+              </a:rPr>
+              <a:t>做什么</a:t>
+            </a:r>
+            <a:endParaRPr sz="880"/>
           </a:p>
         </p:txBody>
       </p:sp>
@@ -13759,36 +14027,60 @@
         </p:nvSpPr>
         <p:spPr>
           <a:xfrm>
-            <a:off x="8261909" y="2377440"/>
-            <a:ext cx="3161690" cy="786384"/>
-          </a:xfrm>
-          <a:prstGeom prst="rect">
-            <a:avLst/>
-          </a:prstGeom>
-          <a:noFill/>
-        </p:spPr>
-        <p:txBody>
-          <a:bodyPr wrap="square" lIns="0" tIns="0" rIns="0" bIns="0" rtlCol="0" anchor="t"/>
+            <a:off x="8261909" y="2390775"/>
+            <a:ext cx="3161690" cy="495300"/>
+          </a:xfrm>
+          <a:prstGeom prst="rect">
+            <a:avLst/>
+          </a:prstGeom>
+          <a:noFill/>
+        </p:spPr>
+        <p:txBody>
+          <a:bodyPr wrap="square" lIns="0" tIns="0" rIns="0" bIns="0" anchor="t">
+            <a:noAutofit/>
+          </a:bodyPr>
           <a:lstStyle/>
           <a:p>
             <a:pPr marL="0" indent="0" algn="l">
               <a:lnSpc>
-                <a:spcPts val="2300"/>
+                <a:spcPct val="120000"/>
               </a:lnSpc>
               <a:buNone/>
-            </a:pPr>
-            <a:r>
-              <a:rPr lang="en-US" sz="1700" b="1" dirty="0">
+              <a:defRPr sz="1200" b="0"/>
+            </a:pPr>
+            <a:r>
+              <a:rPr sz="1200" b="0">
                 <a:solidFill>
                   <a:srgbClr val="2A1C0E"/>
                 </a:solidFill>
-                <a:latin typeface="微软雅黑" pitchFamily="34" charset="0"/>
-                <a:ea typeface="微软雅黑" pitchFamily="34" charset="-122"/>
-                <a:cs typeface="微软雅黑" pitchFamily="34" charset="-120"/>
-              </a:rPr>
-              <a:t>结论要可复核，还不能泄露个体</a:t>
-            </a:r>
-            <a:endParaRPr lang="en-US" sz="1700" dirty="0"/>
+                <a:latin typeface="微软雅黑"/>
+                <a:ea typeface="微软雅黑"/>
+                <a:cs typeface="微软雅黑"/>
+              </a:rPr>
+              <a:t>基于客群统计生成可复核的洞察，</a:t>
+            </a:r>
+            <a:endParaRPr sz="1700"/>
+          </a:p>
+          <a:p>
+            <a:pPr marL="0" indent="0" algn="l">
+              <a:lnSpc>
+                <a:spcPct val="120000"/>
+              </a:lnSpc>
+              <a:buNone/>
+              <a:defRPr sz="1200" b="0"/>
+            </a:pPr>
+            <a:r>
+              <a:rPr sz="1200" b="0">
+                <a:solidFill>
+                  <a:srgbClr val="2A1C0E"/>
+                </a:solidFill>
+                <a:latin typeface="微软雅黑"/>
+                <a:ea typeface="微软雅黑"/>
+                <a:cs typeface="微软雅黑"/>
+              </a:rPr>
+              <a:t>同时保护个体隐私。</a:t>
+            </a:r>
+            <a:endParaRPr sz="1700"/>
           </a:p>
         </p:txBody>
       </p:sp>
@@ -13800,7 +14092,7 @@
         </p:nvSpPr>
         <p:spPr>
           <a:xfrm>
-            <a:off x="8261909" y="3310128"/>
+            <a:off x="8261909" y="2981325"/>
             <a:ext cx="3161690" cy="182880"/>
           </a:xfrm>
           <a:prstGeom prst="rect">
@@ -13809,24 +14101,24 @@
           <a:noFill/>
         </p:spPr>
         <p:txBody>
-          <a:bodyPr wrap="square" lIns="0" tIns="0" rIns="0" bIns="0" rtlCol="0" anchor="t"/>
-          <a:lstStyle/>
-          <a:p>
-            <a:pPr marL="0" indent="0" algn="l">
-              <a:buNone/>
-            </a:pPr>
-            <a:r>
-              <a:rPr lang="en-US" sz="880" b="1" dirty="0">
+          <a:bodyPr wrap="square" lIns="0" tIns="0" rIns="0" bIns="0" anchor="t"/>
+          <a:lstStyle/>
+          <a:p>
+            <a:pPr marL="0" indent="0" algn="l">
+              <a:buNone/>
+            </a:pPr>
+            <a:r>
+              <a:rPr sz="880" b="1">
                 <a:solidFill>
                   <a:srgbClr val="A87A10"/>
                 </a:solidFill>
-                <a:latin typeface="微软雅黑" pitchFamily="34" charset="0"/>
-                <a:ea typeface="微软雅黑" pitchFamily="34" charset="-122"/>
-                <a:cs typeface="微软雅黑" pitchFamily="34" charset="-120"/>
-              </a:rPr>
-              <a:t>解法</a:t>
-            </a:r>
-            <a:endParaRPr lang="en-US" sz="880" dirty="0"/>
+                <a:latin typeface="微软雅黑"/>
+                <a:ea typeface="微软雅黑"/>
+                <a:cs typeface="微软雅黑"/>
+              </a:rPr>
+              <a:t>用什么技术</a:t>
+            </a:r>
+            <a:endParaRPr sz="880"/>
           </a:p>
         </p:txBody>
       </p:sp>
@@ -13838,8 +14130,8 @@
         </p:nvSpPr>
         <p:spPr>
           <a:xfrm>
-            <a:off x="8261909" y="3529584"/>
-            <a:ext cx="3161690" cy="2103120"/>
+            <a:off x="8261909" y="3209925"/>
+            <a:ext cx="3161690" cy="2422779"/>
           </a:xfrm>
           <a:prstGeom prst="roundRect">
             <a:avLst>
@@ -13865,36 +14157,138 @@
         </p:nvSpPr>
         <p:spPr>
           <a:xfrm>
-            <a:off x="8389925" y="3675888"/>
-            <a:ext cx="2905658" cy="1828800"/>
-          </a:xfrm>
-          <a:prstGeom prst="rect">
-            <a:avLst/>
-          </a:prstGeom>
-          <a:noFill/>
-        </p:spPr>
-        <p:txBody>
-          <a:bodyPr wrap="square" lIns="0" tIns="0" rIns="0" bIns="0" rtlCol="0" anchor="t"/>
-          <a:lstStyle/>
-          <a:p>
-            <a:pPr marL="0" indent="0" algn="l">
-              <a:lnSpc>
-                <a:spcPts val="1800"/>
-              </a:lnSpc>
-              <a:buNone/>
-            </a:pPr>
-            <a:r>
-              <a:rPr lang="en-US" sz="1200" dirty="0">
-                <a:solidFill>
-                  <a:srgbClr val="2A1C0E"/>
-                </a:solidFill>
-                <a:latin typeface="微软雅黑" pitchFamily="34" charset="0"/>
-                <a:ea typeface="微软雅黑" pitchFamily="34" charset="-122"/>
-                <a:cs typeface="微软雅黑" pitchFamily="34" charset="-120"/>
-              </a:rPr>
-              <a:t>数字只来自事实登记表；STAT 诊断的 Wilson 区间由 Guard 独立重算；任一格 &lt; 20 人整组抑制。</a:t>
-            </a:r>
-            <a:endParaRPr lang="en-US" sz="1200" dirty="0"/>
+            <a:off x="8389925" y="3343275"/>
+            <a:ext cx="2905658" cy="2162175"/>
+          </a:xfrm>
+          <a:prstGeom prst="rect">
+            <a:avLst/>
+          </a:prstGeom>
+          <a:noFill/>
+        </p:spPr>
+        <p:txBody>
+          <a:bodyPr wrap="square" lIns="0" tIns="0" rIns="0" bIns="0" anchor="t">
+            <a:noAutofit/>
+          </a:bodyPr>
+          <a:lstStyle/>
+          <a:p>
+            <a:pPr>
+              <a:spcAft>
+                <a:spcPts val="700"/>
+              </a:spcAft>
+              <a:defRPr sz="1200" b="0">
+                <a:solidFill>
+                  <a:srgbClr val="2C2115"/>
+                </a:solidFill>
+                <a:latin typeface="微软雅黑"/>
+                <a:ea typeface="微软雅黑"/>
+                <a:cs typeface="微软雅黑"/>
+              </a:defRPr>
+            </a:pPr>
+            <a:r>
+              <a:t>配置清单（YAML）统一分析口径，测试样例检查逻辑，版本校验便于追溯，事实登记表提供数据。</a:t>
+            </a:r>
+          </a:p>
+          <a:p>
+            <a:pPr>
+              <a:spcAft>
+                <a:spcPts val="250"/>
+              </a:spcAft>
+              <a:defRPr sz="1200" b="0">
+                <a:solidFill>
+                  <a:srgbClr val="2C2115"/>
+                </a:solidFill>
+                <a:latin typeface="微软雅黑"/>
+                <a:ea typeface="微软雅黑"/>
+                <a:cs typeface="微软雅黑"/>
+              </a:defRPr>
+            </a:pPr>
+            <a:r>
+              <a:rPr b="1">
+                <a:solidFill>
+                  <a:srgbClr val="B77B00"/>
+                </a:solidFill>
+              </a:rPr>
+              <a:t>关键实现</a:t>
+            </a:r>
+            <a:endParaRPr b="1">
+              <a:solidFill>
+                <a:srgbClr val="B77B00"/>
+              </a:solidFill>
+            </a:endParaRPr>
+          </a:p>
+          <a:p>
+            <a:pPr>
+              <a:spcAft>
+                <a:spcPts val="300"/>
+              </a:spcAft>
+              <a:defRPr sz="1200" b="0">
+                <a:solidFill>
+                  <a:srgbClr val="2C2115"/>
+                </a:solidFill>
+                <a:latin typeface="微软雅黑"/>
+                <a:ea typeface="微软雅黑"/>
+                <a:cs typeface="微软雅黑"/>
+              </a:defRPr>
+            </a:pPr>
+            <a:r>
+              <a:rPr b="1"/>
+              <a:t>难点：结论可复核，个体不暴露</a:t>
+            </a:r>
+            <a:endParaRPr b="1"/>
+          </a:p>
+          <a:p>
+            <a:pPr>
+              <a:spcAft>
+                <a:spcPts val="300"/>
+              </a:spcAft>
+              <a:defRPr sz="1200" b="0">
+                <a:solidFill>
+                  <a:srgbClr val="2C2115"/>
+                </a:solidFill>
+                <a:latin typeface="微软雅黑"/>
+                <a:ea typeface="微软雅黑"/>
+                <a:cs typeface="微软雅黑"/>
+              </a:defRPr>
+            </a:pPr>
+            <a:r>
+              <a:t>Guard 独立重算 Wilson 置信区间，核对统计结论依据。</a:t>
+            </a:r>
+          </a:p>
+          <a:p>
+            <a:pPr>
+              <a:spcAft>
+                <a:spcPts val="300"/>
+              </a:spcAft>
+              <a:defRPr sz="1200" b="0">
+                <a:solidFill>
+                  <a:srgbClr val="2C2115"/>
+                </a:solidFill>
+                <a:latin typeface="微软雅黑"/>
+                <a:ea typeface="微软雅黑"/>
+                <a:cs typeface="微软雅黑"/>
+              </a:defRPr>
+            </a:pPr>
+            <a:r>
+              <a:t>任一分格少于 20 人时，整组结果不展示。</a:t>
+            </a:r>
+          </a:p>
+          <a:p>
+            <a:pPr>
+              <a:spcAft>
+                <a:spcPts val="300"/>
+              </a:spcAft>
+              <a:defRPr sz="1200" b="0">
+                <a:solidFill>
+                  <a:srgbClr val="2C2115"/>
+                </a:solidFill>
+                <a:latin typeface="微软雅黑"/>
+                <a:ea typeface="微软雅黑"/>
+                <a:cs typeface="微软雅黑"/>
+              </a:defRPr>
+            </a:pPr>
+            <a:r>
+              <a:t>防止通过其他分格反推个体信息。</a:t>
+            </a:r>
           </a:p>
         </p:txBody>
       </p:sp>
@@ -13915,24 +14309,24 @@
           <a:noFill/>
         </p:spPr>
         <p:txBody>
-          <a:bodyPr wrap="square" lIns="0" tIns="0" rIns="0" bIns="0" rtlCol="0" anchor="t"/>
-          <a:lstStyle/>
-          <a:p>
-            <a:pPr marL="0" indent="0" algn="l">
-              <a:buNone/>
-            </a:pPr>
-            <a:r>
-              <a:rPr lang="en-US" sz="850" dirty="0">
+          <a:bodyPr wrap="square" lIns="0" tIns="0" rIns="0" bIns="0" anchor="t"/>
+          <a:lstStyle/>
+          <a:p>
+            <a:pPr marL="0" indent="0" algn="l">
+              <a:buNone/>
+            </a:pPr>
+            <a:r>
+              <a:rPr sz="850">
                 <a:solidFill>
                   <a:srgbClr val="96897B"/>
                 </a:solidFill>
-                <a:latin typeface="微软雅黑" pitchFamily="34" charset="0"/>
-                <a:ea typeface="微软雅黑" pitchFamily="34" charset="-122"/>
-                <a:cs typeface="微软雅黑" pitchFamily="34" charset="-120"/>
-              </a:rPr>
-              <a:t>技术栈：FastAPI + BGE-M3（1024 维）+ jieba + pyahocorasick；claude-agent-sdk 0.1.50；内容即代码（YAML Manifest + fixtures，代码包整体 hash）。工具集：find_tags / get_tag_details / find_capabilities / check_plan / submit_result。规模：六通道召回 → RRF(k=60) → BGE 重排；3 技能 / 24 指标定义 / 4 基准 / 6 类图表原子。</a:t>
-            </a:r>
-            <a:endParaRPr lang="en-US" sz="850" dirty="0"/>
+                <a:latin typeface="微软雅黑"/>
+                <a:ea typeface="微软雅黑"/>
+                <a:cs typeface="微软雅黑"/>
+              </a:rPr>
+              <a:t>实现重点：检索口径精确匹配，方案与权限统一校验，统计结论独立复核。</a:t>
+            </a:r>
+            <a:endParaRPr sz="850"/>
           </a:p>
         </p:txBody>
       </p:sp>
@@ -14069,7 +14463,7 @@
               <a:buNone/>
             </a:pPr>
             <a:r>
-              <a:rPr lang="en-US" sz="2600" b="1" dirty="0">
+              <a:rPr lang="zh-CN" altLang="en-US" sz="2600" b="1" dirty="0">
                 <a:solidFill>
                   <a:srgbClr val="2A1C0E"/>
                 </a:solidFill>
@@ -14077,9 +14471,38 @@
                 <a:ea typeface="微软雅黑" pitchFamily="34" charset="-122"/>
                 <a:cs typeface="微软雅黑" pitchFamily="34" charset="-120"/>
               </a:rPr>
-              <a:t>五道闸门，把模型输出变成可复核结论</a:t>
-            </a:r>
-            <a:endParaRPr lang="en-US" sz="2600" dirty="0"/>
+              <a:t>五道闸门，让 </a:t>
+            </a:r>
+            <a:r>
+              <a:rPr lang="en-US" altLang="zh-CN" sz="2600" b="1" dirty="0">
+                <a:solidFill>
+                  <a:srgbClr val="2A1C0E"/>
+                </a:solidFill>
+                <a:latin typeface="微软雅黑" pitchFamily="34" charset="0"/>
+                <a:ea typeface="微软雅黑" pitchFamily="34" charset="-122"/>
+                <a:cs typeface="微软雅黑" pitchFamily="34" charset="-120"/>
+              </a:rPr>
+              <a:t>Agent “</a:t>
+            </a:r>
+            <a:r>
+              <a:rPr lang="zh-CN" altLang="en-US" sz="2600" b="1" dirty="0">
+                <a:solidFill>
+                  <a:srgbClr val="2A1C0E"/>
+                </a:solidFill>
+                <a:latin typeface="微软雅黑" pitchFamily="34" charset="0"/>
+                <a:ea typeface="微软雅黑" pitchFamily="34" charset="-122"/>
+                <a:cs typeface="微软雅黑" pitchFamily="34" charset="-120"/>
+              </a:rPr>
+              <a:t>会思考，但不能乱执行”</a:t>
+            </a:r>
+            <a:endParaRPr lang="zh-CN" altLang="en-US" sz="2600" b="1" dirty="0">
+              <a:solidFill>
+                <a:srgbClr val="2A1C0E"/>
+              </a:solidFill>
+              <a:latin typeface="微软雅黑" pitchFamily="34" charset="0"/>
+              <a:ea typeface="微软雅黑" pitchFamily="34" charset="-122"/>
+              <a:cs typeface="微软雅黑" pitchFamily="34" charset="-120"/>
+            </a:endParaRPr>
           </a:p>
         </p:txBody>
       </p:sp>
@@ -14202,7 +14625,7 @@
               <a:buNone/>
             </a:pPr>
             <a:r>
-              <a:rPr lang="en-US" sz="1200" b="1" dirty="0">
+              <a:rPr lang="zh-CN" altLang="en-US" sz="1200" b="1" dirty="0">
                 <a:solidFill>
                   <a:srgbClr val="2A1C0E"/>
                 </a:solidFill>
@@ -14210,9 +14633,16 @@
                 <a:ea typeface="微软雅黑" pitchFamily="34" charset="-122"/>
                 <a:cs typeface="微软雅黑" pitchFamily="34" charset="-120"/>
               </a:rPr>
-              <a:t>条件必须绑证据</a:t>
-            </a:r>
-            <a:endParaRPr lang="en-US" sz="1200" dirty="0"/>
+              <a:t>每个条件，都必须“有据可查”</a:t>
+            </a:r>
+            <a:endParaRPr lang="zh-CN" altLang="en-US" sz="1200" b="1" dirty="0">
+              <a:solidFill>
+                <a:srgbClr val="2A1C0E"/>
+              </a:solidFill>
+              <a:latin typeface="微软雅黑" pitchFamily="34" charset="0"/>
+              <a:ea typeface="微软雅黑" pitchFamily="34" charset="-122"/>
+              <a:cs typeface="微软雅黑" pitchFamily="34" charset="-120"/>
+            </a:endParaRPr>
           </a:p>
         </p:txBody>
       </p:sp>
@@ -14243,6 +14673,17 @@
               <a:buNone/>
             </a:pPr>
             <a:r>
+              <a:rPr lang="zh-CN" altLang="en-US" sz="960" dirty="0">
+                <a:solidFill>
+                  <a:srgbClr val="5B4F43"/>
+                </a:solidFill>
+                <a:latin typeface="微软雅黑" pitchFamily="34" charset="0"/>
+                <a:ea typeface="微软雅黑" pitchFamily="34" charset="-122"/>
+                <a:cs typeface="微软雅黑" pitchFamily="34" charset="-120"/>
+              </a:rPr>
+              <a:t>每个圈选条件必须绑定语义检索证据，模型不能凭空创造标签或业务口径</a:t>
+            </a:r>
+            <a:r>
               <a:rPr lang="en-US" sz="960" dirty="0">
                 <a:solidFill>
                   <a:srgbClr val="5B4F43"/>
@@ -14251,7 +14692,7 @@
                 <a:ea typeface="微软雅黑" pitchFamily="34" charset="-122"/>
                 <a:cs typeface="微软雅黑" pitchFamily="34" charset="-120"/>
               </a:rPr>
-              <a:t>每个条件绑定本轮检索到的证据；假设类解释也要指向已发布证据。</a:t>
+              <a:t>。</a:t>
             </a:r>
             <a:endParaRPr lang="en-US" sz="960" dirty="0"/>
           </a:p>
@@ -14376,7 +14817,7 @@
               <a:buNone/>
             </a:pPr>
             <a:r>
-              <a:rPr lang="en-US" sz="1200" b="1" dirty="0">
+              <a:rPr lang="zh-CN" altLang="en-US" sz="1200" b="1" dirty="0">
                 <a:solidFill>
                   <a:srgbClr val="2A1C0E"/>
                 </a:solidFill>
@@ -14384,9 +14825,16 @@
                 <a:ea typeface="微软雅黑" pitchFamily="34" charset="-122"/>
                 <a:cs typeface="微软雅黑" pitchFamily="34" charset="-120"/>
               </a:rPr>
-              <a:t>输出是条件树，不是自然语言</a:t>
-            </a:r>
-            <a:endParaRPr lang="en-US" sz="1200" dirty="0"/>
+              <a:t>模型只生成结构化条件，不直接给结论</a:t>
+            </a:r>
+            <a:endParaRPr lang="zh-CN" altLang="en-US" sz="1200" b="1" dirty="0">
+              <a:solidFill>
+                <a:srgbClr val="2A1C0E"/>
+              </a:solidFill>
+              <a:latin typeface="微软雅黑" pitchFamily="34" charset="0"/>
+              <a:ea typeface="微软雅黑" pitchFamily="34" charset="-122"/>
+              <a:cs typeface="微软雅黑" pitchFamily="34" charset="-120"/>
+            </a:endParaRPr>
           </a:p>
         </p:txBody>
       </p:sp>
@@ -14417,7 +14865,7 @@
               <a:buNone/>
             </a:pPr>
             <a:r>
-              <a:rPr lang="en-US" sz="960" dirty="0">
+              <a:rPr lang="zh-CN" altLang="en-US" sz="960" dirty="0">
                 <a:solidFill>
                   <a:srgbClr val="5B4F43"/>
                 </a:solidFill>
@@ -14425,9 +14873,16 @@
                 <a:ea typeface="微软雅黑" pitchFamily="34" charset="-122"/>
                 <a:cs typeface="微软雅黑" pitchFamily="34" charset="-120"/>
               </a:rPr>
-              <a:t>深度 ≤ 8、AND/OR 组 1–30 项、clause_id 唯一，不合法直接 SCHEMA_INVALID。</a:t>
-            </a:r>
-            <a:endParaRPr lang="en-US" sz="960" dirty="0"/>
+              <a:t>输出统一转换为标准条件树，并执行层级、逻辑关系、唯一标识等结构校验；不合规结果直接拦截。</a:t>
+            </a:r>
+            <a:endParaRPr lang="zh-CN" altLang="en-US" sz="960" dirty="0">
+              <a:solidFill>
+                <a:srgbClr val="5B4F43"/>
+              </a:solidFill>
+              <a:latin typeface="微软雅黑" pitchFamily="34" charset="0"/>
+              <a:ea typeface="微软雅黑" pitchFamily="34" charset="-122"/>
+              <a:cs typeface="微软雅黑" pitchFamily="34" charset="-120"/>
+            </a:endParaRPr>
           </a:p>
         </p:txBody>
       </p:sp>
@@ -14550,7 +15005,7 @@
               <a:buNone/>
             </a:pPr>
             <a:r>
-              <a:rPr lang="en-US" sz="1200" b="1" dirty="0">
+              <a:rPr lang="zh-CN" altLang="en-US" sz="1200" b="1" dirty="0">
                 <a:solidFill>
                   <a:srgbClr val="2A1C0E"/>
                 </a:solidFill>
@@ -14558,9 +15013,38 @@
                 <a:ea typeface="微软雅黑" pitchFamily="34" charset="-122"/>
                 <a:cs typeface="微软雅黑" pitchFamily="34" charset="-120"/>
               </a:rPr>
-              <a:t>五维确定性 Guard</a:t>
-            </a:r>
-            <a:endParaRPr lang="en-US" sz="1200" dirty="0"/>
+              <a:t>五维 </a:t>
+            </a:r>
+            <a:r>
+              <a:rPr lang="en-US" altLang="zh-CN" sz="1200" b="1" dirty="0">
+                <a:solidFill>
+                  <a:srgbClr val="2A1C0E"/>
+                </a:solidFill>
+                <a:latin typeface="微软雅黑" pitchFamily="34" charset="0"/>
+                <a:ea typeface="微软雅黑" pitchFamily="34" charset="-122"/>
+                <a:cs typeface="微软雅黑" pitchFamily="34" charset="-120"/>
+              </a:rPr>
+              <a:t>Guard，</a:t>
+            </a:r>
+            <a:r>
+              <a:rPr lang="zh-CN" altLang="en-US" sz="1200" b="1" dirty="0">
+                <a:solidFill>
+                  <a:srgbClr val="2A1C0E"/>
+                </a:solidFill>
+                <a:latin typeface="微软雅黑" pitchFamily="34" charset="0"/>
+                <a:ea typeface="微软雅黑" pitchFamily="34" charset="-122"/>
+                <a:cs typeface="微软雅黑" pitchFamily="34" charset="-120"/>
+              </a:rPr>
+              <a:t>逐项做确定性校验</a:t>
+            </a:r>
+            <a:endParaRPr lang="zh-CN" altLang="en-US" sz="1200" b="1" dirty="0">
+              <a:solidFill>
+                <a:srgbClr val="2A1C0E"/>
+              </a:solidFill>
+              <a:latin typeface="微软雅黑" pitchFamily="34" charset="0"/>
+              <a:ea typeface="微软雅黑" pitchFamily="34" charset="-122"/>
+              <a:cs typeface="微软雅黑" pitchFamily="34" charset="-120"/>
+            </a:endParaRPr>
           </a:p>
         </p:txBody>
       </p:sp>
@@ -14591,6 +15075,17 @@
               <a:buNone/>
             </a:pPr>
             <a:r>
+              <a:rPr lang="zh-CN" altLang="en-US" sz="960" dirty="0">
+                <a:solidFill>
+                  <a:srgbClr val="5B4F43"/>
+                </a:solidFill>
+                <a:latin typeface="微软雅黑" pitchFamily="34" charset="0"/>
+                <a:ea typeface="微软雅黑" pitchFamily="34" charset="-122"/>
+                <a:cs typeface="微软雅黑" pitchFamily="34" charset="-120"/>
+              </a:rPr>
+              <a:t>围绕来源、数值、时间、冻结条件、需求覆盖五个维度逐项检查，关键规则不交给模型自行判断</a:t>
+            </a:r>
+            <a:r>
               <a:rPr lang="en-US" sz="960" dirty="0">
                 <a:solidFill>
                   <a:srgbClr val="5B4F43"/>
@@ -14599,7 +15094,7 @@
                 <a:ea typeface="微软雅黑" pitchFamily="34" charset="-122"/>
                 <a:cs typeface="微软雅黑" pitchFamily="34" charset="-120"/>
               </a:rPr>
-              <a:t>来源 / 数值 / 时间 / 冻结条件 / 需求覆盖，逐条核验，纯 Python。</a:t>
+              <a:t>。</a:t>
             </a:r>
             <a:endParaRPr lang="en-US" sz="960" dirty="0"/>
           </a:p>
@@ -14724,7 +15219,7 @@
               <a:buNone/>
             </a:pPr>
             <a:r>
-              <a:rPr lang="en-US" sz="1200" b="1" dirty="0">
+              <a:rPr lang="zh-CN" altLang="en-US" sz="1200" b="1" dirty="0">
                 <a:solidFill>
                   <a:srgbClr val="2A1C0E"/>
                 </a:solidFill>
@@ -14732,9 +15227,16 @@
                 <a:ea typeface="微软雅黑" pitchFamily="34" charset="-122"/>
                 <a:cs typeface="微软雅黑" pitchFamily="34" charset="-120"/>
               </a:rPr>
-              <a:t>资格检索时重算，只收紧</a:t>
-            </a:r>
-            <a:endParaRPr lang="en-US" sz="1200" dirty="0"/>
+              <a:t>每次使用，都重新校验权限与资格</a:t>
+            </a:r>
+            <a:endParaRPr lang="zh-CN" altLang="en-US" sz="1200" b="1" dirty="0">
+              <a:solidFill>
+                <a:srgbClr val="2A1C0E"/>
+              </a:solidFill>
+              <a:latin typeface="微软雅黑" pitchFamily="34" charset="0"/>
+              <a:ea typeface="微软雅黑" pitchFamily="34" charset="-122"/>
+              <a:cs typeface="微软雅黑" pitchFamily="34" charset="-120"/>
+            </a:endParaRPr>
           </a:p>
         </p:txBody>
       </p:sp>
@@ -14765,7 +15267,7 @@
               <a:buNone/>
             </a:pPr>
             <a:r>
-              <a:rPr lang="en-US" sz="960" dirty="0">
+              <a:rPr lang="zh-CN" altLang="en-US" sz="960" dirty="0">
                 <a:solidFill>
                   <a:srgbClr val="5B4F43"/>
                 </a:solidFill>
@@ -14773,9 +15275,16 @@
                 <a:ea typeface="微软雅黑" pitchFamily="34" charset="-122"/>
                 <a:cs typeface="微软雅黑" pitchFamily="34" charset="-120"/>
               </a:rPr>
-              <a:t>空资格必须返回空结果；权限永不写入快照或索引。</a:t>
-            </a:r>
-            <a:endParaRPr lang="en-US" sz="960" dirty="0"/>
+              <a:t>标签资格实时计算；无权限、未发布、已失效标签无法进入最终方案，历史结果也不能绕过当前规则。</a:t>
+            </a:r>
+            <a:endParaRPr lang="zh-CN" altLang="en-US" sz="960" dirty="0">
+              <a:solidFill>
+                <a:srgbClr val="5B4F43"/>
+              </a:solidFill>
+              <a:latin typeface="微软雅黑" pitchFamily="34" charset="0"/>
+              <a:ea typeface="微软雅黑" pitchFamily="34" charset="-122"/>
+              <a:cs typeface="微软雅黑" pitchFamily="34" charset="-120"/>
+            </a:endParaRPr>
           </a:p>
         </p:txBody>
       </p:sp>
@@ -14898,7 +15407,7 @@
               <a:buNone/>
             </a:pPr>
             <a:r>
-              <a:rPr lang="en-US" sz="1200" b="1" dirty="0">
+              <a:rPr lang="zh-CN" altLang="en-US" sz="1200" b="1" dirty="0">
                 <a:solidFill>
                   <a:srgbClr val="2A1C0E"/>
                 </a:solidFill>
@@ -14906,9 +15415,16 @@
                 <a:ea typeface="微软雅黑" pitchFamily="34" charset="-122"/>
                 <a:cs typeface="微软雅黑" pitchFamily="34" charset="-120"/>
               </a:rPr>
-              <a:t>auto_execute 恒为 false</a:t>
-            </a:r>
-            <a:endParaRPr lang="en-US" sz="1200" dirty="0"/>
+              <a:t>默认“不自动执行”，最终动作由人确认</a:t>
+            </a:r>
+            <a:endParaRPr lang="zh-CN" altLang="en-US" sz="1200" b="1" dirty="0">
+              <a:solidFill>
+                <a:srgbClr val="2A1C0E"/>
+              </a:solidFill>
+              <a:latin typeface="微软雅黑" pitchFamily="34" charset="0"/>
+              <a:ea typeface="微软雅黑" pitchFamily="34" charset="-122"/>
+              <a:cs typeface="微软雅黑" pitchFamily="34" charset="-120"/>
+            </a:endParaRPr>
           </a:p>
         </p:txBody>
       </p:sp>
@@ -14939,7 +15455,7 @@
               <a:buNone/>
             </a:pPr>
             <a:r>
-              <a:rPr lang="en-US" sz="960" dirty="0">
+              <a:rPr lang="en-US" altLang="zh-CN" sz="960" dirty="0">
                 <a:solidFill>
                   <a:srgbClr val="5B4F43"/>
                 </a:solidFill>
@@ -14947,9 +15463,71 @@
                 <a:ea typeface="微软雅黑" pitchFamily="34" charset="-122"/>
                 <a:cs typeface="微软雅黑" pitchFamily="34" charset="-120"/>
               </a:rPr>
-              <a:t>合法 DSL 也只是待确认候选，真正执行 SQL 的只有 Java 对象群模块。</a:t>
-            </a:r>
-            <a:endParaRPr lang="en-US" sz="960" dirty="0"/>
+              <a:t>Agent </a:t>
+            </a:r>
+            <a:r>
+              <a:rPr lang="zh-CN" altLang="en-US" sz="960" dirty="0">
+                <a:solidFill>
+                  <a:srgbClr val="5B4F43"/>
+                </a:solidFill>
+                <a:latin typeface="微软雅黑" pitchFamily="34" charset="0"/>
+                <a:ea typeface="微软雅黑" pitchFamily="34" charset="-122"/>
+                <a:cs typeface="微软雅黑" pitchFamily="34" charset="-120"/>
+              </a:rPr>
+              <a:t>只生成待确认的客群方案，不直接执行 </a:t>
+            </a:r>
+            <a:r>
+              <a:rPr lang="en-US" altLang="zh-CN" sz="960" dirty="0">
+                <a:solidFill>
+                  <a:srgbClr val="5B4F43"/>
+                </a:solidFill>
+                <a:latin typeface="微软雅黑" pitchFamily="34" charset="0"/>
+                <a:ea typeface="微软雅黑" pitchFamily="34" charset="-122"/>
+                <a:cs typeface="微软雅黑" pitchFamily="34" charset="-120"/>
+              </a:rPr>
+              <a:t>SQL；</a:t>
+            </a:r>
+            <a:r>
+              <a:rPr lang="zh-CN" altLang="en-US" sz="960" dirty="0">
+                <a:solidFill>
+                  <a:srgbClr val="5B4F43"/>
+                </a:solidFill>
+                <a:latin typeface="微软雅黑" pitchFamily="34" charset="0"/>
+                <a:ea typeface="微软雅黑" pitchFamily="34" charset="-122"/>
+                <a:cs typeface="微软雅黑" pitchFamily="34" charset="-120"/>
+              </a:rPr>
+              <a:t>真正建群仍由现有 </a:t>
+            </a:r>
+            <a:r>
+              <a:rPr lang="en-US" altLang="zh-CN" sz="960" dirty="0">
+                <a:solidFill>
+                  <a:srgbClr val="5B4F43"/>
+                </a:solidFill>
+                <a:latin typeface="微软雅黑" pitchFamily="34" charset="0"/>
+                <a:ea typeface="微软雅黑" pitchFamily="34" charset="-122"/>
+                <a:cs typeface="微软雅黑" pitchFamily="34" charset="-120"/>
+              </a:rPr>
+              <a:t>Java </a:t>
+            </a:r>
+            <a:r>
+              <a:rPr lang="zh-CN" altLang="en-US" sz="960" dirty="0">
+                <a:solidFill>
+                  <a:srgbClr val="5B4F43"/>
+                </a:solidFill>
+                <a:latin typeface="微软雅黑" pitchFamily="34" charset="0"/>
+                <a:ea typeface="微软雅黑" pitchFamily="34" charset="-122"/>
+                <a:cs typeface="微软雅黑" pitchFamily="34" charset="-120"/>
+              </a:rPr>
+              <a:t>模块和人工确认完成。</a:t>
+            </a:r>
+            <a:endParaRPr lang="zh-CN" altLang="en-US" sz="960" dirty="0">
+              <a:solidFill>
+                <a:srgbClr val="5B4F43"/>
+              </a:solidFill>
+              <a:latin typeface="微软雅黑" pitchFamily="34" charset="0"/>
+              <a:ea typeface="微软雅黑" pitchFamily="34" charset="-122"/>
+              <a:cs typeface="微软雅黑" pitchFamily="34" charset="-120"/>
+            </a:endParaRPr>
           </a:p>
         </p:txBody>
       </p:sp>
@@ -15332,7 +15910,7 @@
               <a:buNone/>
             </a:pPr>
             <a:r>
-              <a:rPr lang="en-US" sz="920" b="1" dirty="0">
+              <a:rPr lang="zh-CN" altLang="en-US" sz="920" b="1" dirty="0">
                 <a:solidFill>
                   <a:srgbClr val="A87A10"/>
                 </a:solidFill>
@@ -15340,9 +15918,16 @@
                 <a:ea typeface="微软雅黑" pitchFamily="34" charset="-122"/>
                 <a:cs typeface="微软雅黑" pitchFamily="34" charset="-120"/>
               </a:rPr>
-              <a:t>怎么读这三个零</a:t>
-            </a:r>
-            <a:endParaRPr lang="en-US" sz="920" dirty="0"/>
+              <a:t>这三个“0”意味着什么？</a:t>
+            </a:r>
+            <a:endParaRPr lang="zh-CN" altLang="en-US" sz="920" b="1" dirty="0">
+              <a:solidFill>
+                <a:srgbClr val="A87A10"/>
+              </a:solidFill>
+              <a:latin typeface="微软雅黑" pitchFamily="34" charset="0"/>
+              <a:ea typeface="微软雅黑" pitchFamily="34" charset="-122"/>
+              <a:cs typeface="微软雅黑" pitchFamily="34" charset="-120"/>
+            </a:endParaRPr>
           </a:p>
         </p:txBody>
       </p:sp>
@@ -15373,7 +15958,7 @@
               <a:buNone/>
             </a:pPr>
             <a:r>
-              <a:rPr lang="en-US" sz="880" dirty="0">
+              <a:rPr lang="zh-CN" altLang="en-US" sz="880" dirty="0">
                 <a:solidFill>
                   <a:srgbClr val="96897B"/>
                 </a:solidFill>
@@ -15381,47 +15966,16 @@
                 <a:ea typeface="微软雅黑" pitchFamily="34" charset="-122"/>
                 <a:cs typeface="微软雅黑" pitchFamily="34" charset="-120"/>
               </a:rPr>
-              <a:t>600 题封存集上的三项零违规。失败案例里 20 / 26 是预算收敛，不是语义绑错 —— 该结论只对本批题与 max_turns=10、预算 1 USD 成立。</a:t>
-            </a:r>
-            <a:endParaRPr lang="en-US" sz="880" dirty="0"/>
-          </a:p>
-        </p:txBody>
-      </p:sp>
-      <p:sp>
-        <p:nvSpPr>
-          <p:cNvPr id="41" name="Text 39"/>
-          <p:cNvSpPr/>
-          <p:nvPr/>
-        </p:nvSpPr>
-        <p:spPr>
-          <a:xfrm>
-            <a:off x="566928" y="6345936"/>
-            <a:ext cx="10143439" cy="310896"/>
-          </a:xfrm>
-          <a:prstGeom prst="rect">
-            <a:avLst/>
-          </a:prstGeom>
-          <a:noFill/>
-        </p:spPr>
-        <p:txBody>
-          <a:bodyPr wrap="square" lIns="0" tIns="0" rIns="0" bIns="0" rtlCol="0" anchor="t"/>
-          <a:lstStyle/>
-          <a:p>
-            <a:pPr marL="0" indent="0" algn="l">
-              <a:buNone/>
-            </a:pPr>
-            <a:r>
-              <a:rPr lang="en-US" sz="850" dirty="0">
-                <a:solidFill>
-                  <a:srgbClr val="96897B"/>
-                </a:solidFill>
-                <a:latin typeface="微软雅黑" pitchFamily="34" charset="0"/>
-                <a:ea typeface="微软雅黑" pitchFamily="34" charset="-122"/>
-                <a:cs typeface="微软雅黑" pitchFamily="34" charset="-120"/>
-              </a:rPr>
-              <a:t>来源：tagpilot_agent/guards/（五维校验与冻结条件）；tag_semantic/server.py（auto_execute 硬编码为 false）；docs/validation/语义索引层建设验收记录.md（零违规计数）。</a:t>
-            </a:r>
-            <a:endParaRPr lang="en-US" sz="850" dirty="0"/>
+              <a:t>在封存测试集中，系统未出现幻觉标签、越权标签或错误自动执行。即使模型判断出错，也会被确定性规则拦截，而不是直接进入生产动作。</a:t>
+            </a:r>
+            <a:endParaRPr lang="zh-CN" altLang="en-US" sz="880" dirty="0">
+              <a:solidFill>
+                <a:srgbClr val="96897B"/>
+              </a:solidFill>
+              <a:latin typeface="微软雅黑" pitchFamily="34" charset="0"/>
+              <a:ea typeface="微软雅黑" pitchFamily="34" charset="-122"/>
+              <a:cs typeface="微软雅黑" pitchFamily="34" charset="-120"/>
+            </a:endParaRPr>
           </a:p>
         </p:txBody>
       </p:sp>
@@ -15558,7 +16112,7 @@
               <a:buNone/>
             </a:pPr>
             <a:r>
-              <a:rPr lang="en-US" sz="2600" b="1" dirty="0">
+              <a:rPr lang="zh-CN" altLang="en-US" sz="2600" b="1" dirty="0">
                 <a:solidFill>
                   <a:srgbClr val="2A1C0E"/>
                 </a:solidFill>
@@ -15566,9 +16120,16 @@
                 <a:ea typeface="微软雅黑" pitchFamily="34" charset="-122"/>
                 <a:cs typeface="微软雅黑" pitchFamily="34" charset="-120"/>
               </a:rPr>
-              <a:t>五个用例全过，涨分来自配置而不是换数据</a:t>
-            </a:r>
-            <a:endParaRPr lang="en-US" sz="2600" dirty="0"/>
+              <a:t>五类用例通过，配置优化提升召回覆盖率并降低响应时延</a:t>
+            </a:r>
+            <a:endParaRPr lang="zh-CN" altLang="en-US" sz="2600" b="1" dirty="0">
+              <a:solidFill>
+                <a:srgbClr val="2A1C0E"/>
+              </a:solidFill>
+              <a:latin typeface="微软雅黑" pitchFamily="34" charset="0"/>
+              <a:ea typeface="微软雅黑" pitchFamily="34" charset="-122"/>
+              <a:cs typeface="微软雅黑" pitchFamily="34" charset="-120"/>
+            </a:endParaRPr>
           </a:p>
         </p:txBody>
       </p:sp>
@@ -15668,7 +16229,7 @@
               <a:buNone/>
             </a:pPr>
             <a:r>
-              <a:rPr lang="en-US" sz="960" b="1" dirty="0">
+              <a:rPr lang="zh-CN" altLang="en-US" sz="960" b="1" dirty="0">
                 <a:solidFill>
                   <a:srgbClr val="C25A0E"/>
                 </a:solidFill>
@@ -15676,9 +16237,16 @@
                 <a:ea typeface="微软雅黑" pitchFamily="34" charset="-122"/>
                 <a:cs typeface="微软雅黑" pitchFamily="34" charset="-120"/>
               </a:rPr>
-              <a:t>正常</a:t>
-            </a:r>
-            <a:endParaRPr lang="en-US" sz="960" dirty="0"/>
+              <a:t>用例1｜正常需求</a:t>
+            </a:r>
+            <a:endParaRPr lang="zh-CN" altLang="en-US" sz="960" b="1" dirty="0">
+              <a:solidFill>
+                <a:srgbClr val="C25A0E"/>
+              </a:solidFill>
+              <a:latin typeface="微软雅黑" pitchFamily="34" charset="0"/>
+              <a:ea typeface="微软雅黑" pitchFamily="34" charset="-122"/>
+              <a:cs typeface="微软雅黑" pitchFamily="34" charset="-120"/>
+            </a:endParaRPr>
           </a:p>
         </p:txBody>
       </p:sp>
@@ -15857,7 +16425,7 @@
               <a:buNone/>
             </a:pPr>
             <a:r>
-              <a:rPr lang="en-US" sz="960" b="1" dirty="0">
+              <a:rPr lang="zh-CN" altLang="en-US" sz="960" b="1" dirty="0">
                 <a:solidFill>
                   <a:srgbClr val="C25A0E"/>
                 </a:solidFill>
@@ -15865,9 +16433,16 @@
                 <a:ea typeface="微软雅黑" pitchFamily="34" charset="-122"/>
                 <a:cs typeface="微软雅黑" pitchFamily="34" charset="-120"/>
               </a:rPr>
-              <a:t>边界 · 口径</a:t>
-            </a:r>
-            <a:endParaRPr lang="en-US" sz="960" dirty="0"/>
+              <a:t>用例2｜边界口径</a:t>
+            </a:r>
+            <a:endParaRPr lang="zh-CN" altLang="en-US" sz="960" b="1" dirty="0">
+              <a:solidFill>
+                <a:srgbClr val="C25A0E"/>
+              </a:solidFill>
+              <a:latin typeface="微软雅黑" pitchFamily="34" charset="0"/>
+              <a:ea typeface="微软雅黑" pitchFamily="34" charset="-122"/>
+              <a:cs typeface="微软雅黑" pitchFamily="34" charset="-120"/>
+            </a:endParaRPr>
           </a:p>
         </p:txBody>
       </p:sp>
@@ -15906,7 +16481,18 @@
                 <a:ea typeface="微软雅黑" pitchFamily="34" charset="-122"/>
                 <a:cs typeface="微软雅黑" pitchFamily="34" charset="-120"/>
               </a:rPr>
-              <a:t>「超过 100 万」跨桶</a:t>
+              <a:t>「超过 100 万」</a:t>
+            </a:r>
+            <a:r>
+              <a:rPr lang="zh-CN" altLang="en-US" sz="960" b="1" dirty="0">
+                <a:solidFill>
+                  <a:srgbClr val="2A1C0E"/>
+                </a:solidFill>
+                <a:latin typeface="微软雅黑" pitchFamily="34" charset="0"/>
+                <a:ea typeface="微软雅黑" pitchFamily="34" charset="-122"/>
+                <a:cs typeface="微软雅黑" pitchFamily="34" charset="-120"/>
+              </a:rPr>
+              <a:t>无精确表达</a:t>
             </a:r>
             <a:r>
               <a:rPr lang="en-US" sz="960" dirty="0">
@@ -15917,9 +16503,27 @@
                 <a:ea typeface="微软雅黑" pitchFamily="34" charset="-122"/>
                 <a:cs typeface="微软雅黑" pitchFamily="34" charset="-120"/>
               </a:rPr>
-              <a:t> → INEXPRESSIBLE，拒绝近似</a:t>
-            </a:r>
-            <a:endParaRPr lang="en-US" sz="960" dirty="0"/>
+              <a:t> → </a:t>
+            </a:r>
+            <a:r>
+              <a:rPr lang="zh-CN" altLang="en-US" sz="960" dirty="0">
+                <a:solidFill>
+                  <a:srgbClr val="5B4F43"/>
+                </a:solidFill>
+                <a:latin typeface="微软雅黑" pitchFamily="34" charset="0"/>
+                <a:ea typeface="微软雅黑" pitchFamily="34" charset="-122"/>
+                <a:cs typeface="微软雅黑" pitchFamily="34" charset="-120"/>
+              </a:rPr>
+              <a:t>拒绝近似替换，提示无法表达</a:t>
+            </a:r>
+            <a:endParaRPr lang="zh-CN" altLang="en-US" sz="960" dirty="0">
+              <a:solidFill>
+                <a:srgbClr val="5B4F43"/>
+              </a:solidFill>
+              <a:latin typeface="微软雅黑" pitchFamily="34" charset="0"/>
+              <a:ea typeface="微软雅黑" pitchFamily="34" charset="-122"/>
+              <a:cs typeface="微软雅黑" pitchFamily="34" charset="-120"/>
+            </a:endParaRPr>
           </a:p>
         </p:txBody>
       </p:sp>
@@ -16046,7 +16650,7 @@
               <a:buNone/>
             </a:pPr>
             <a:r>
-              <a:rPr lang="en-US" sz="960" b="1" dirty="0">
+              <a:rPr lang="zh-CN" altLang="en-US" sz="960" b="1" dirty="0">
                 <a:solidFill>
                   <a:srgbClr val="C25A0E"/>
                 </a:solidFill>
@@ -16054,9 +16658,16 @@
                 <a:ea typeface="微软雅黑" pitchFamily="34" charset="-122"/>
                 <a:cs typeface="微软雅黑" pitchFamily="34" charset="-120"/>
               </a:rPr>
-              <a:t>异常 · 越权</a:t>
-            </a:r>
-            <a:endParaRPr lang="en-US" sz="960" dirty="0"/>
+              <a:t>用例3｜异常权限</a:t>
+            </a:r>
+            <a:endParaRPr lang="zh-CN" altLang="en-US" sz="960" b="1" dirty="0">
+              <a:solidFill>
+                <a:srgbClr val="C25A0E"/>
+              </a:solidFill>
+              <a:latin typeface="微软雅黑" pitchFamily="34" charset="0"/>
+              <a:ea typeface="微软雅黑" pitchFamily="34" charset="-122"/>
+              <a:cs typeface="微软雅黑" pitchFamily="34" charset="-120"/>
+            </a:endParaRPr>
           </a:p>
         </p:txBody>
       </p:sp>
@@ -16106,9 +16717,49 @@
                 <a:ea typeface="微软雅黑" pitchFamily="34" charset="-122"/>
                 <a:cs typeface="微软雅黑" pitchFamily="34" charset="-120"/>
               </a:rPr>
-              <a:t> → INELIGIBLE_TAG，条件被拒</a:t>
-            </a:r>
-            <a:endParaRPr lang="en-US" sz="960" dirty="0"/>
+              <a:t> → </a:t>
+            </a:r>
+            <a:r>
+              <a:rPr lang="zh-CN" altLang="en-US" sz="960" dirty="0">
+                <a:solidFill>
+                  <a:srgbClr val="5B4F43"/>
+                </a:solidFill>
+                <a:latin typeface="微软雅黑" pitchFamily="34" charset="0"/>
+                <a:ea typeface="微软雅黑" pitchFamily="34" charset="-122"/>
+                <a:cs typeface="微软雅黑" pitchFamily="34" charset="-120"/>
+              </a:rPr>
+              <a:t>返回 </a:t>
+            </a:r>
+            <a:r>
+              <a:rPr lang="en-US" altLang="zh-CN" sz="960" dirty="0">
+                <a:solidFill>
+                  <a:srgbClr val="5B4F43"/>
+                </a:solidFill>
+                <a:latin typeface="微软雅黑" pitchFamily="34" charset="0"/>
+                <a:ea typeface="微软雅黑" pitchFamily="34" charset="-122"/>
+                <a:cs typeface="微软雅黑" pitchFamily="34" charset="-120"/>
+              </a:rPr>
+              <a:t>INELIGIBLE_TAG，</a:t>
+            </a:r>
+            <a:r>
+              <a:rPr lang="zh-CN" altLang="en-US" sz="960" dirty="0">
+                <a:solidFill>
+                  <a:srgbClr val="5B4F43"/>
+                </a:solidFill>
+                <a:latin typeface="微软雅黑" pitchFamily="34" charset="0"/>
+                <a:ea typeface="微软雅黑" pitchFamily="34" charset="-122"/>
+                <a:cs typeface="微软雅黑" pitchFamily="34" charset="-120"/>
+              </a:rPr>
+              <a:t>拒绝该条件</a:t>
+            </a:r>
+            <a:endParaRPr lang="zh-CN" altLang="en-US" sz="960" dirty="0">
+              <a:solidFill>
+                <a:srgbClr val="5B4F43"/>
+              </a:solidFill>
+              <a:latin typeface="微软雅黑" pitchFamily="34" charset="0"/>
+              <a:ea typeface="微软雅黑" pitchFamily="34" charset="-122"/>
+              <a:cs typeface="微软雅黑" pitchFamily="34" charset="-120"/>
+            </a:endParaRPr>
           </a:p>
         </p:txBody>
       </p:sp>
@@ -16235,7 +16886,7 @@
               <a:buNone/>
             </a:pPr>
             <a:r>
-              <a:rPr lang="en-US" sz="960" b="1" dirty="0">
+              <a:rPr lang="zh-CN" altLang="en-US" sz="960" b="1" dirty="0">
                 <a:solidFill>
                   <a:srgbClr val="C25A0E"/>
                 </a:solidFill>
@@ -16243,9 +16894,16 @@
                 <a:ea typeface="微软雅黑" pitchFamily="34" charset="-122"/>
                 <a:cs typeface="微软雅黑" pitchFamily="34" charset="-120"/>
               </a:rPr>
-              <a:t>澄清</a:t>
-            </a:r>
-            <a:endParaRPr lang="en-US" sz="960" dirty="0"/>
+              <a:t>用例4｜信息缺失</a:t>
+            </a:r>
+            <a:endParaRPr lang="zh-CN" altLang="en-US" sz="960" b="1" dirty="0">
+              <a:solidFill>
+                <a:srgbClr val="C25A0E"/>
+              </a:solidFill>
+              <a:latin typeface="微软雅黑" pitchFamily="34" charset="0"/>
+              <a:ea typeface="微软雅黑" pitchFamily="34" charset="-122"/>
+              <a:cs typeface="微软雅黑" pitchFamily="34" charset="-120"/>
+            </a:endParaRPr>
           </a:p>
         </p:txBody>
       </p:sp>
@@ -16295,7 +16953,29 @@
                 <a:ea typeface="微软雅黑" pitchFamily="34" charset="-122"/>
                 <a:cs typeface="微软雅黑" pitchFamily="34" charset="-120"/>
               </a:rPr>
-              <a:t> → NEEDS_USER_INPUT，最多 3 问</a:t>
+              <a:t> → </a:t>
+            </a:r>
+            <a:r>
+              <a:rPr lang="zh-CN" altLang="en-US" sz="960" dirty="0">
+                <a:solidFill>
+                  <a:srgbClr val="5B4F43"/>
+                </a:solidFill>
+                <a:latin typeface="微软雅黑" pitchFamily="34" charset="0"/>
+                <a:ea typeface="微软雅黑" pitchFamily="34" charset="-122"/>
+                <a:cs typeface="微软雅黑" pitchFamily="34" charset="-120"/>
+              </a:rPr>
+              <a:t>请求补充条件，避免自行推断</a:t>
+            </a:r>
+            <a:r>
+              <a:rPr lang="en-US" sz="960" dirty="0">
+                <a:solidFill>
+                  <a:srgbClr val="5B4F43"/>
+                </a:solidFill>
+                <a:latin typeface="微软雅黑" pitchFamily="34" charset="0"/>
+                <a:ea typeface="微软雅黑" pitchFamily="34" charset="-122"/>
+                <a:cs typeface="微软雅黑" pitchFamily="34" charset="-120"/>
+              </a:rPr>
+              <a:t>，最多 3 问</a:t>
             </a:r>
             <a:endParaRPr lang="en-US" sz="960" dirty="0"/>
           </a:p>
@@ -16424,7 +17104,7 @@
               <a:buNone/>
             </a:pPr>
             <a:r>
-              <a:rPr lang="en-US" sz="960" b="1" dirty="0">
+              <a:rPr lang="zh-CN" altLang="en-US" sz="960" b="1" dirty="0">
                 <a:solidFill>
                   <a:srgbClr val="C25A0E"/>
                 </a:solidFill>
@@ -16432,9 +17112,16 @@
                 <a:ea typeface="微软雅黑" pitchFamily="34" charset="-122"/>
                 <a:cs typeface="微软雅黑" pitchFamily="34" charset="-120"/>
               </a:rPr>
-              <a:t>边界 · 码值</a:t>
-            </a:r>
-            <a:endParaRPr lang="en-US" sz="960" dirty="0"/>
+              <a:t>用例5｜未知码值</a:t>
+            </a:r>
+            <a:endParaRPr lang="zh-CN" altLang="en-US" sz="960" b="1" dirty="0">
+              <a:solidFill>
+                <a:srgbClr val="C25A0E"/>
+              </a:solidFill>
+              <a:latin typeface="微软雅黑" pitchFamily="34" charset="0"/>
+              <a:ea typeface="微软雅黑" pitchFamily="34" charset="-122"/>
+              <a:cs typeface="微软雅黑" pitchFamily="34" charset="-120"/>
+            </a:endParaRPr>
           </a:p>
         </p:txBody>
       </p:sp>
@@ -16484,9 +17171,27 @@
                 <a:ea typeface="微软雅黑" pitchFamily="34" charset="-122"/>
                 <a:cs typeface="微软雅黑" pitchFamily="34" charset="-120"/>
               </a:rPr>
-              <a:t> → 必须声明 unknown_policy</a:t>
-            </a:r>
-            <a:endParaRPr lang="en-US" sz="960" dirty="0"/>
+              <a:t> → </a:t>
+            </a:r>
+            <a:r>
+              <a:rPr lang="zh-CN" altLang="en-US" sz="960" dirty="0">
+                <a:solidFill>
+                  <a:srgbClr val="5B4F43"/>
+                </a:solidFill>
+                <a:latin typeface="微软雅黑" pitchFamily="34" charset="0"/>
+                <a:ea typeface="微软雅黑" pitchFamily="34" charset="-122"/>
+                <a:cs typeface="微软雅黑" pitchFamily="34" charset="-120"/>
+              </a:rPr>
+              <a:t>强制明确未知值处理方式，避免漏选误选</a:t>
+            </a:r>
+            <a:endParaRPr lang="zh-CN" altLang="en-US" sz="960" dirty="0">
+              <a:solidFill>
+                <a:srgbClr val="5B4F43"/>
+              </a:solidFill>
+              <a:latin typeface="微软雅黑" pitchFamily="34" charset="0"/>
+              <a:ea typeface="微软雅黑" pitchFamily="34" charset="-122"/>
+              <a:cs typeface="微软雅黑" pitchFamily="34" charset="-120"/>
+            </a:endParaRPr>
           </a:p>
         </p:txBody>
       </p:sp>
@@ -16613,7 +17318,7 @@
               <a:buNone/>
             </a:pPr>
             <a:r>
-              <a:rPr lang="en-US" sz="1200" b="1" dirty="0">
+              <a:rPr lang="zh-CN" altLang="en-US" sz="1200" b="1" dirty="0">
                 <a:solidFill>
                   <a:srgbClr val="2A1C0E"/>
                 </a:solidFill>
@@ -16621,9 +17326,16 @@
                 <a:ea typeface="微软雅黑" pitchFamily="34" charset="-122"/>
                 <a:cs typeface="微软雅黑" pitchFamily="34" charset="-120"/>
               </a:rPr>
-              <a:t>A/B 对照：分是从哪来的</a:t>
-            </a:r>
-            <a:endParaRPr lang="en-US" sz="1200" dirty="0"/>
+              <a:t>量化效果对比</a:t>
+            </a:r>
+            <a:endParaRPr lang="zh-CN" altLang="en-US" sz="1200" b="1" dirty="0">
+              <a:solidFill>
+                <a:srgbClr val="2A1C0E"/>
+              </a:solidFill>
+              <a:latin typeface="微软雅黑" pitchFamily="34" charset="0"/>
+              <a:ea typeface="微软雅黑" pitchFamily="34" charset="-122"/>
+              <a:cs typeface="微软雅黑" pitchFamily="34" charset="-120"/>
+            </a:endParaRPr>
           </a:p>
         </p:txBody>
       </p:sp>
@@ -16674,7 +17386,7 @@
               <a:buNone/>
             </a:pPr>
             <a:r>
-              <a:rPr lang="en-US" sz="1900" b="1" dirty="0">
+              <a:rPr lang="zh-CN" altLang="en-US" sz="1400" b="1" dirty="0">
                 <a:solidFill>
                   <a:srgbClr val="C25A0E"/>
                 </a:solidFill>
@@ -16682,47 +17394,38 @@
                 <a:ea typeface="Cambria" pitchFamily="34" charset="-122"/>
                 <a:cs typeface="Cambria" pitchFamily="34" charset="-120"/>
               </a:rPr>
-              <a:t>0</a:t>
-            </a:r>
-            <a:endParaRPr lang="en-US" sz="1900" dirty="0"/>
-          </a:p>
-        </p:txBody>
-      </p:sp>
-      <p:sp>
-        <p:nvSpPr>
-          <p:cNvPr id="34" name="Text 32"/>
-          <p:cNvSpPr/>
-          <p:nvPr/>
-        </p:nvSpPr>
-        <p:spPr>
-          <a:xfrm>
-            <a:off x="7534656" y="2084832"/>
-            <a:ext cx="3888943" cy="219456"/>
-          </a:xfrm>
-          <a:prstGeom prst="rect">
-            <a:avLst/>
-          </a:prstGeom>
-          <a:noFill/>
-        </p:spPr>
-        <p:txBody>
-          <a:bodyPr wrap="square" lIns="0" tIns="0" rIns="0" bIns="0" rtlCol="0" anchor="t"/>
-          <a:lstStyle/>
-          <a:p>
-            <a:pPr marL="0" indent="0" algn="l">
-              <a:buNone/>
-            </a:pPr>
-            <a:r>
-              <a:rPr lang="en-US" sz="940" b="1" dirty="0">
-                <a:solidFill>
-                  <a:srgbClr val="2A1C0E"/>
-                </a:solidFill>
-                <a:latin typeface="微软雅黑" pitchFamily="34" charset="0"/>
-                <a:ea typeface="微软雅黑" pitchFamily="34" charset="-122"/>
-                <a:cs typeface="微软雅黑" pitchFamily="34" charset="-120"/>
-              </a:rPr>
-              <a:t>纯换语义数据的 L1 净收益</a:t>
-            </a:r>
-            <a:endParaRPr lang="en-US" sz="940" dirty="0"/>
+              <a:t>① 复杂圈选：人工逐步查找，</a:t>
+            </a:r>
+            <a:r>
+              <a:rPr lang="en-US" altLang="zh-CN" sz="1400" b="1" dirty="0">
+                <a:solidFill>
+                  <a:srgbClr val="C25A0E"/>
+                </a:solidFill>
+                <a:latin typeface="Cambria" pitchFamily="34" charset="0"/>
+                <a:ea typeface="Cambria" pitchFamily="34" charset="-122"/>
+                <a:cs typeface="Cambria" pitchFamily="34" charset="-120"/>
+              </a:rPr>
+              <a:t>AI </a:t>
+            </a:r>
+            <a:r>
+              <a:rPr lang="zh-CN" altLang="en-US" sz="1400" b="1" dirty="0">
+                <a:solidFill>
+                  <a:srgbClr val="C25A0E"/>
+                </a:solidFill>
+                <a:latin typeface="Cambria" pitchFamily="34" charset="0"/>
+                <a:ea typeface="Cambria" pitchFamily="34" charset="-122"/>
+                <a:cs typeface="Cambria" pitchFamily="34" charset="-120"/>
+              </a:rPr>
+              <a:t>辅助生成方案</a:t>
+            </a:r>
+            <a:endParaRPr lang="zh-CN" altLang="en-US" sz="1400" b="1" dirty="0">
+              <a:solidFill>
+                <a:srgbClr val="C25A0E"/>
+              </a:solidFill>
+              <a:latin typeface="Cambria" pitchFamily="34" charset="0"/>
+              <a:ea typeface="Cambria" pitchFamily="34" charset="-122"/>
+              <a:cs typeface="Cambria" pitchFamily="34" charset="-120"/>
+            </a:endParaRPr>
           </a:p>
         </p:txBody>
       </p:sp>
@@ -16734,7 +17437,7 @@
         </p:nvSpPr>
         <p:spPr>
           <a:xfrm>
-            <a:off x="7534656" y="2304288"/>
+            <a:off x="7534656" y="2084578"/>
             <a:ext cx="3888943" cy="310896"/>
           </a:xfrm>
           <a:prstGeom prst="rect">
@@ -16753,7 +17456,7 @@
               <a:buNone/>
             </a:pPr>
             <a:r>
-              <a:rPr lang="en-US" sz="860" dirty="0">
+              <a:rPr lang="zh-CN" altLang="en-US" sz="860" dirty="0">
                 <a:solidFill>
                   <a:srgbClr val="5B4F43"/>
                 </a:solidFill>
@@ -16761,9 +17464,76 @@
                 <a:ea typeface="微软雅黑" pitchFamily="34" charset="-122"/>
                 <a:cs typeface="微软雅黑" pitchFamily="34" charset="-120"/>
               </a:rPr>
-              <a:t>换语义不涨召回 —— 我们把这个负结果也放上来。</a:t>
-            </a:r>
-            <a:endParaRPr lang="en-US" sz="860" dirty="0"/>
+              <a:t>人工：找标签、核口径、组条件，约 0.5～1 天。</a:t>
+            </a:r>
+            <a:endParaRPr lang="zh-CN" altLang="en-US" sz="860" dirty="0">
+              <a:solidFill>
+                <a:srgbClr val="5B4F43"/>
+              </a:solidFill>
+              <a:latin typeface="微软雅黑" pitchFamily="34" charset="0"/>
+              <a:ea typeface="微软雅黑" pitchFamily="34" charset="-122"/>
+              <a:cs typeface="微软雅黑" pitchFamily="34" charset="-120"/>
+            </a:endParaRPr>
+          </a:p>
+          <a:p>
+            <a:pPr marL="0" indent="0" algn="l">
+              <a:lnSpc>
+                <a:spcPts val="1180"/>
+              </a:lnSpc>
+              <a:buNone/>
+            </a:pPr>
+            <a:r>
+              <a:rPr lang="en-US" altLang="zh-CN" sz="860" dirty="0">
+                <a:solidFill>
+                  <a:srgbClr val="5B4F43"/>
+                </a:solidFill>
+                <a:latin typeface="微软雅黑" pitchFamily="34" charset="0"/>
+                <a:ea typeface="微软雅黑" pitchFamily="34" charset="-122"/>
+                <a:cs typeface="微软雅黑" pitchFamily="34" charset="-120"/>
+              </a:rPr>
+              <a:t>AI </a:t>
+            </a:r>
+            <a:r>
+              <a:rPr lang="zh-CN" altLang="en-US" sz="860" dirty="0">
+                <a:solidFill>
+                  <a:srgbClr val="5B4F43"/>
+                </a:solidFill>
+                <a:latin typeface="微软雅黑" pitchFamily="34" charset="0"/>
+                <a:ea typeface="微软雅黑" pitchFamily="34" charset="-122"/>
+                <a:cs typeface="微软雅黑" pitchFamily="34" charset="-120"/>
+              </a:rPr>
+              <a:t>辅助：自动匹配标签、校验条件并生成待确认方案，系统 </a:t>
+            </a:r>
+            <a:r>
+              <a:rPr lang="en-US" altLang="zh-CN" sz="860" dirty="0">
+                <a:solidFill>
+                  <a:srgbClr val="5B4F43"/>
+                </a:solidFill>
+                <a:latin typeface="微软雅黑" pitchFamily="34" charset="0"/>
+                <a:ea typeface="微软雅黑" pitchFamily="34" charset="-122"/>
+                <a:cs typeface="微软雅黑" pitchFamily="34" charset="-120"/>
+              </a:rPr>
+              <a:t>p95 </a:t>
+            </a:r>
+            <a:r>
+              <a:rPr lang="zh-CN" altLang="en-US" sz="860" dirty="0">
+                <a:solidFill>
+                  <a:srgbClr val="5B4F43"/>
+                </a:solidFill>
+                <a:latin typeface="微软雅黑" pitchFamily="34" charset="0"/>
+                <a:ea typeface="微软雅黑" pitchFamily="34" charset="-122"/>
+                <a:cs typeface="微软雅黑" pitchFamily="34" charset="-120"/>
+              </a:rPr>
+              <a:t>响应时延 18.3 秒。</a:t>
+            </a:r>
+            <a:endParaRPr lang="zh-CN" altLang="en-US" sz="860" dirty="0">
+              <a:solidFill>
+                <a:srgbClr val="5B4F43"/>
+              </a:solidFill>
+              <a:latin typeface="微软雅黑" pitchFamily="34" charset="0"/>
+              <a:ea typeface="微软雅黑" pitchFamily="34" charset="-122"/>
+              <a:cs typeface="微软雅黑" pitchFamily="34" charset="-120"/>
+            </a:endParaRPr>
           </a:p>
         </p:txBody>
       </p:sp>
@@ -16791,7 +17561,7 @@
               <a:buNone/>
             </a:pPr>
             <a:r>
-              <a:rPr lang="en-US" sz="1900" b="1" dirty="0">
+              <a:rPr lang="zh-CN" altLang="en-US" sz="1400" b="1" dirty="0">
                 <a:solidFill>
                   <a:srgbClr val="C25A0E"/>
                 </a:solidFill>
@@ -16799,47 +17569,38 @@
                 <a:ea typeface="Cambria" pitchFamily="34" charset="-122"/>
                 <a:cs typeface="Cambria" pitchFamily="34" charset="-120"/>
               </a:rPr>
-              <a:t>12</a:t>
-            </a:r>
-            <a:endParaRPr lang="en-US" sz="1900" dirty="0"/>
-          </a:p>
-        </p:txBody>
-      </p:sp>
-      <p:sp>
-        <p:nvSpPr>
-          <p:cNvPr id="37" name="Text 35"/>
-          <p:cNvSpPr/>
-          <p:nvPr/>
-        </p:nvSpPr>
-        <p:spPr>
-          <a:xfrm>
-            <a:off x="7534656" y="2926080"/>
-            <a:ext cx="3888943" cy="219456"/>
-          </a:xfrm>
-          <a:prstGeom prst="rect">
-            <a:avLst/>
-          </a:prstGeom>
-          <a:noFill/>
-        </p:spPr>
-        <p:txBody>
-          <a:bodyPr wrap="square" lIns="0" tIns="0" rIns="0" bIns="0" rtlCol="0" anchor="t"/>
-          <a:lstStyle/>
-          <a:p>
-            <a:pPr marL="0" indent="0" algn="l">
-              <a:buNone/>
-            </a:pPr>
-            <a:r>
-              <a:rPr lang="en-US" sz="940" b="1" dirty="0">
-                <a:solidFill>
-                  <a:srgbClr val="2A1C0E"/>
-                </a:solidFill>
-                <a:latin typeface="微软雅黑" pitchFamily="34" charset="0"/>
-                <a:ea typeface="微软雅黑" pitchFamily="34" charset="-122"/>
-                <a:cs typeface="微软雅黑" pitchFamily="34" charset="-120"/>
-              </a:rPr>
-              <a:t>个召回缺口，全部由 NFKC 配置修复</a:t>
-            </a:r>
-            <a:endParaRPr lang="en-US" sz="940" dirty="0"/>
+              <a:t>② 深度分析：人工整理分析，</a:t>
+            </a:r>
+            <a:r>
+              <a:rPr lang="en-US" altLang="zh-CN" sz="1400" b="1" dirty="0">
+                <a:solidFill>
+                  <a:srgbClr val="C25A0E"/>
+                </a:solidFill>
+                <a:latin typeface="Cambria" pitchFamily="34" charset="0"/>
+                <a:ea typeface="Cambria" pitchFamily="34" charset="-122"/>
+                <a:cs typeface="Cambria" pitchFamily="34" charset="-120"/>
+              </a:rPr>
+              <a:t>AI </a:t>
+            </a:r>
+            <a:r>
+              <a:rPr lang="zh-CN" altLang="en-US" sz="1400" b="1" dirty="0">
+                <a:solidFill>
+                  <a:srgbClr val="C25A0E"/>
+                </a:solidFill>
+                <a:latin typeface="Cambria" pitchFamily="34" charset="0"/>
+                <a:ea typeface="Cambria" pitchFamily="34" charset="-122"/>
+                <a:cs typeface="Cambria" pitchFamily="34" charset="-120"/>
+              </a:rPr>
+              <a:t>辅助形成洞察</a:t>
+            </a:r>
+            <a:endParaRPr lang="zh-CN" altLang="en-US" sz="1400" b="1" dirty="0">
+              <a:solidFill>
+                <a:srgbClr val="C25A0E"/>
+              </a:solidFill>
+              <a:latin typeface="Cambria" pitchFamily="34" charset="0"/>
+              <a:ea typeface="Cambria" pitchFamily="34" charset="-122"/>
+              <a:cs typeface="Cambria" pitchFamily="34" charset="-120"/>
+            </a:endParaRPr>
           </a:p>
         </p:txBody>
       </p:sp>
@@ -16851,8 +17612,8 @@
         </p:nvSpPr>
         <p:spPr>
           <a:xfrm>
-            <a:off x="7534656" y="3145536"/>
-            <a:ext cx="3888943" cy="310896"/>
+            <a:off x="7534910" y="2926080"/>
+            <a:ext cx="3888740" cy="530860"/>
           </a:xfrm>
           <a:prstGeom prst="rect">
             <a:avLst/>
@@ -16870,7 +17631,7 @@
               <a:buNone/>
             </a:pPr>
             <a:r>
-              <a:rPr lang="en-US" sz="860" dirty="0">
+              <a:rPr lang="zh-CN" altLang="en-US" sz="860" dirty="0">
                 <a:solidFill>
                   <a:srgbClr val="5B4F43"/>
                 </a:solidFill>
@@ -16878,9 +17639,54 @@
                 <a:ea typeface="微软雅黑" pitchFamily="34" charset="-122"/>
                 <a:cs typeface="微软雅黑" pitchFamily="34" charset="-120"/>
               </a:rPr>
-              <a:t>A→C、B→D 各恢复 12 个原子条件，覆盖率 99.36% → 100%。</a:t>
-            </a:r>
-            <a:endParaRPr lang="en-US" sz="860" dirty="0"/>
+              <a:t>人工：核对指标、分析差异、整理结论，约 1～2 天。</a:t>
+            </a:r>
+            <a:endParaRPr lang="zh-CN" altLang="en-US" sz="860" dirty="0">
+              <a:solidFill>
+                <a:srgbClr val="5B4F43"/>
+              </a:solidFill>
+              <a:latin typeface="微软雅黑" pitchFamily="34" charset="0"/>
+              <a:ea typeface="微软雅黑" pitchFamily="34" charset="-122"/>
+              <a:cs typeface="微软雅黑" pitchFamily="34" charset="-120"/>
+            </a:endParaRPr>
+          </a:p>
+          <a:p>
+            <a:pPr marL="0" indent="0" algn="l">
+              <a:lnSpc>
+                <a:spcPts val="1180"/>
+              </a:lnSpc>
+              <a:buNone/>
+            </a:pPr>
+            <a:r>
+              <a:rPr lang="en-US" altLang="zh-CN" sz="860" dirty="0">
+                <a:solidFill>
+                  <a:srgbClr val="5B4F43"/>
+                </a:solidFill>
+                <a:latin typeface="微软雅黑" pitchFamily="34" charset="0"/>
+                <a:ea typeface="微软雅黑" pitchFamily="34" charset="-122"/>
+                <a:cs typeface="微软雅黑" pitchFamily="34" charset="-120"/>
+              </a:rPr>
+              <a:t>AI </a:t>
+            </a:r>
+            <a:r>
+              <a:rPr lang="zh-CN" altLang="en-US" sz="860" dirty="0">
+                <a:solidFill>
+                  <a:srgbClr val="5B4F43"/>
+                </a:solidFill>
+                <a:latin typeface="微软雅黑" pitchFamily="34" charset="0"/>
+                <a:ea typeface="微软雅黑" pitchFamily="34" charset="-122"/>
+                <a:cs typeface="微软雅黑" pitchFamily="34" charset="-120"/>
+              </a:rPr>
+              <a:t>辅助：汇总客群统计、生成洞察并复核数值依据，完整分析耗时待实测。</a:t>
+            </a:r>
+            <a:endParaRPr lang="zh-CN" altLang="en-US" sz="860" dirty="0">
+              <a:solidFill>
+                <a:srgbClr val="5B4F43"/>
+              </a:solidFill>
+              <a:latin typeface="微软雅黑" pitchFamily="34" charset="0"/>
+              <a:ea typeface="微软雅黑" pitchFamily="34" charset="-122"/>
+              <a:cs typeface="微软雅黑" pitchFamily="34" charset="-120"/>
+            </a:endParaRPr>
           </a:p>
         </p:txBody>
       </p:sp>
@@ -16908,7 +17714,7 @@
               <a:buNone/>
             </a:pPr>
             <a:r>
-              <a:rPr lang="en-US" sz="1900" b="1" dirty="0">
+              <a:rPr lang="zh-CN" altLang="en-US" sz="1400" b="1" dirty="0">
                 <a:solidFill>
                   <a:srgbClr val="C25A0E"/>
                 </a:solidFill>
@@ -16916,47 +17722,38 @@
                 <a:ea typeface="Cambria" pitchFamily="34" charset="-122"/>
                 <a:cs typeface="Cambria" pitchFamily="34" charset="-120"/>
               </a:rPr>
-              <a:t>18.3s</a:t>
-            </a:r>
-            <a:endParaRPr lang="en-US" sz="1900" dirty="0"/>
-          </a:p>
-        </p:txBody>
-      </p:sp>
-      <p:sp>
-        <p:nvSpPr>
-          <p:cNvPr id="40" name="Text 38"/>
-          <p:cNvSpPr/>
-          <p:nvPr/>
-        </p:nvSpPr>
-        <p:spPr>
-          <a:xfrm>
-            <a:off x="7534656" y="3767328"/>
-            <a:ext cx="3888943" cy="219456"/>
-          </a:xfrm>
-          <a:prstGeom prst="rect">
-            <a:avLst/>
-          </a:prstGeom>
-          <a:noFill/>
-        </p:spPr>
-        <p:txBody>
-          <a:bodyPr wrap="square" lIns="0" tIns="0" rIns="0" bIns="0" rtlCol="0" anchor="t"/>
-          <a:lstStyle/>
-          <a:p>
-            <a:pPr marL="0" indent="0" algn="l">
-              <a:buNone/>
-            </a:pPr>
-            <a:r>
-              <a:rPr lang="en-US" sz="940" b="1" dirty="0">
-                <a:solidFill>
-                  <a:srgbClr val="2A1C0E"/>
-                </a:solidFill>
-                <a:latin typeface="微软雅黑" pitchFamily="34" charset="0"/>
-                <a:ea typeface="微软雅黑" pitchFamily="34" charset="-122"/>
-                <a:cs typeface="微软雅黑" pitchFamily="34" charset="-120"/>
-              </a:rPr>
-              <a:t>p95 时延（优化前 81.24s）</a:t>
-            </a:r>
-            <a:endParaRPr lang="en-US" sz="940" dirty="0"/>
+              <a:t>③ 高频任务：人工重复操作，</a:t>
+            </a:r>
+            <a:r>
+              <a:rPr lang="en-US" altLang="zh-CN" sz="1400" b="1" dirty="0">
+                <a:solidFill>
+                  <a:srgbClr val="C25A0E"/>
+                </a:solidFill>
+                <a:latin typeface="Cambria" pitchFamily="34" charset="0"/>
+                <a:ea typeface="Cambria" pitchFamily="34" charset="-122"/>
+                <a:cs typeface="Cambria" pitchFamily="34" charset="-120"/>
+              </a:rPr>
+              <a:t>AI </a:t>
+            </a:r>
+            <a:r>
+              <a:rPr lang="zh-CN" altLang="en-US" sz="1400" b="1" dirty="0">
+                <a:solidFill>
+                  <a:srgbClr val="C25A0E"/>
+                </a:solidFill>
+                <a:latin typeface="Cambria" pitchFamily="34" charset="0"/>
+                <a:ea typeface="Cambria" pitchFamily="34" charset="-122"/>
+                <a:cs typeface="Cambria" pitchFamily="34" charset="-120"/>
+              </a:rPr>
+              <a:t>辅助完成</a:t>
+            </a:r>
+            <a:endParaRPr lang="zh-CN" altLang="en-US" sz="1400" b="1" dirty="0">
+              <a:solidFill>
+                <a:srgbClr val="C25A0E"/>
+              </a:solidFill>
+              <a:latin typeface="Cambria" pitchFamily="34" charset="0"/>
+              <a:ea typeface="Cambria" pitchFamily="34" charset="-122"/>
+              <a:cs typeface="Cambria" pitchFamily="34" charset="-120"/>
+            </a:endParaRPr>
           </a:p>
         </p:txBody>
       </p:sp>
@@ -16968,7 +17765,7 @@
         </p:nvSpPr>
         <p:spPr>
           <a:xfrm>
-            <a:off x="7534656" y="3986784"/>
+            <a:off x="7534656" y="3767709"/>
             <a:ext cx="3888943" cy="310896"/>
           </a:xfrm>
           <a:prstGeom prst="rect">
@@ -16987,7 +17784,7 @@
               <a:buNone/>
             </a:pPr>
             <a:r>
-              <a:rPr lang="en-US" sz="860" dirty="0">
+              <a:rPr lang="zh-CN" altLang="en-US" sz="860" dirty="0">
                 <a:solidFill>
                   <a:srgbClr val="5B4F43"/>
                 </a:solidFill>
@@ -16995,9 +17792,54 @@
                 <a:ea typeface="微软雅黑" pitchFamily="34" charset="-122"/>
                 <a:cs typeface="微软雅黑" pitchFamily="34" charset="-120"/>
               </a:rPr>
-              <a:t>15 例固定回归从 14/15 到 15/15。</a:t>
-            </a:r>
-            <a:endParaRPr lang="en-US" sz="860" dirty="0"/>
+              <a:t>人工：每人每月约 20 次圈选与分析，反复查标签、核口径、组条件。</a:t>
+            </a:r>
+            <a:endParaRPr lang="zh-CN" altLang="en-US" sz="860" dirty="0">
+              <a:solidFill>
+                <a:srgbClr val="5B4F43"/>
+              </a:solidFill>
+              <a:latin typeface="微软雅黑" pitchFamily="34" charset="0"/>
+              <a:ea typeface="微软雅黑" pitchFamily="34" charset="-122"/>
+              <a:cs typeface="微软雅黑" pitchFamily="34" charset="-120"/>
+            </a:endParaRPr>
+          </a:p>
+          <a:p>
+            <a:pPr marL="0" indent="0" algn="l">
+              <a:lnSpc>
+                <a:spcPts val="1180"/>
+              </a:lnSpc>
+              <a:buNone/>
+            </a:pPr>
+            <a:r>
+              <a:rPr lang="en-US" altLang="zh-CN" sz="860" dirty="0">
+                <a:solidFill>
+                  <a:srgbClr val="5B4F43"/>
+                </a:solidFill>
+                <a:latin typeface="微软雅黑" pitchFamily="34" charset="0"/>
+                <a:ea typeface="微软雅黑" pitchFamily="34" charset="-122"/>
+                <a:cs typeface="微软雅黑" pitchFamily="34" charset="-120"/>
+              </a:rPr>
+              <a:t>AI </a:t>
+            </a:r>
+            <a:r>
+              <a:rPr lang="zh-CN" altLang="en-US" sz="860" dirty="0">
+                <a:solidFill>
+                  <a:srgbClr val="5B4F43"/>
+                </a:solidFill>
+                <a:latin typeface="微软雅黑" pitchFamily="34" charset="0"/>
+                <a:ea typeface="微软雅黑" pitchFamily="34" charset="-122"/>
+                <a:cs typeface="微软雅黑" pitchFamily="34" charset="-120"/>
+              </a:rPr>
+              <a:t>辅助：通过自然语言发起需求，自动完成标签匹配与方案草拟，人员集中确认关键口径和结果。</a:t>
+            </a:r>
+            <a:endParaRPr lang="zh-CN" altLang="en-US" sz="860" dirty="0">
+              <a:solidFill>
+                <a:srgbClr val="5B4F43"/>
+              </a:solidFill>
+              <a:latin typeface="微软雅黑" pitchFamily="34" charset="0"/>
+              <a:ea typeface="微软雅黑" pitchFamily="34" charset="-122"/>
+              <a:cs typeface="微软雅黑" pitchFamily="34" charset="-120"/>
+            </a:endParaRPr>
           </a:p>
         </p:txBody>
       </p:sp>
@@ -17025,7 +17867,7 @@
               <a:buNone/>
             </a:pPr>
             <a:r>
-              <a:rPr lang="en-US" sz="1900" b="1" dirty="0">
+              <a:rPr lang="zh-CN" altLang="en-US" sz="1400" b="1" dirty="0">
                 <a:solidFill>
                   <a:srgbClr val="C25A0E"/>
                 </a:solidFill>
@@ -17033,47 +17875,38 @@
                 <a:ea typeface="Cambria" pitchFamily="34" charset="-122"/>
                 <a:cs typeface="Cambria" pitchFamily="34" charset="-120"/>
               </a:rPr>
-              <a:t>200/200</a:t>
-            </a:r>
-            <a:endParaRPr lang="en-US" sz="1900" dirty="0"/>
-          </a:p>
-        </p:txBody>
-      </p:sp>
-      <p:sp>
-        <p:nvSpPr>
-          <p:cNvPr id="43" name="Text 41"/>
-          <p:cNvSpPr/>
-          <p:nvPr/>
-        </p:nvSpPr>
-        <p:spPr>
-          <a:xfrm>
-            <a:off x="7534656" y="4608576"/>
-            <a:ext cx="3888943" cy="219456"/>
-          </a:xfrm>
-          <a:prstGeom prst="rect">
-            <a:avLst/>
-          </a:prstGeom>
-          <a:noFill/>
-        </p:spPr>
-        <p:txBody>
-          <a:bodyPr wrap="square" lIns="0" tIns="0" rIns="0" bIns="0" rtlCol="0" anchor="t"/>
-          <a:lstStyle/>
-          <a:p>
-            <a:pPr marL="0" indent="0" algn="l">
-              <a:buNone/>
-            </a:pPr>
-            <a:r>
-              <a:rPr lang="en-US" sz="940" b="1" dirty="0">
-                <a:solidFill>
-                  <a:srgbClr val="2A1C0E"/>
-                </a:solidFill>
-                <a:latin typeface="微软雅黑" pitchFamily="34" charset="0"/>
-                <a:ea typeface="微软雅黑" pitchFamily="34" charset="-122"/>
-                <a:cs typeface="微软雅黑" pitchFamily="34" charset="-120"/>
-              </a:rPr>
-              <a:t>HOLDOUT 召回 · 128/128 全覆盖</a:t>
-            </a:r>
-            <a:endParaRPr lang="en-US" sz="940" dirty="0"/>
+              <a:t>④ 结果校验：人工逐项核查，</a:t>
+            </a:r>
+            <a:r>
+              <a:rPr lang="en-US" altLang="zh-CN" sz="1400" b="1" dirty="0">
+                <a:solidFill>
+                  <a:srgbClr val="C25A0E"/>
+                </a:solidFill>
+                <a:latin typeface="Cambria" pitchFamily="34" charset="0"/>
+                <a:ea typeface="Cambria" pitchFamily="34" charset="-122"/>
+                <a:cs typeface="Cambria" pitchFamily="34" charset="-120"/>
+              </a:rPr>
+              <a:t>AI </a:t>
+            </a:r>
+            <a:r>
+              <a:rPr lang="zh-CN" altLang="en-US" sz="1400" b="1" dirty="0">
+                <a:solidFill>
+                  <a:srgbClr val="C25A0E"/>
+                </a:solidFill>
+                <a:latin typeface="Cambria" pitchFamily="34" charset="0"/>
+                <a:ea typeface="Cambria" pitchFamily="34" charset="-122"/>
+                <a:cs typeface="Cambria" pitchFamily="34" charset="-120"/>
+              </a:rPr>
+              <a:t>执行统一规则</a:t>
+            </a:r>
+            <a:endParaRPr lang="zh-CN" altLang="en-US" sz="1400" b="1" dirty="0">
+              <a:solidFill>
+                <a:srgbClr val="C25A0E"/>
+              </a:solidFill>
+              <a:latin typeface="Cambria" pitchFamily="34" charset="0"/>
+              <a:ea typeface="Cambria" pitchFamily="34" charset="-122"/>
+              <a:cs typeface="Cambria" pitchFamily="34" charset="-120"/>
+            </a:endParaRPr>
           </a:p>
         </p:txBody>
       </p:sp>
@@ -17085,7 +17918,7 @@
         </p:nvSpPr>
         <p:spPr>
           <a:xfrm>
-            <a:off x="7534656" y="4828032"/>
+            <a:off x="7534656" y="4608957"/>
             <a:ext cx="3888943" cy="310896"/>
           </a:xfrm>
           <a:prstGeom prst="rect">
@@ -17104,7 +17937,7 @@
               <a:buNone/>
             </a:pPr>
             <a:r>
-              <a:rPr lang="en-US" sz="860" dirty="0">
+              <a:rPr lang="zh-CN" altLang="en-US" sz="860" dirty="0">
                 <a:solidFill>
                   <a:srgbClr val="5B4F43"/>
                 </a:solidFill>
@@ -17112,96 +17945,17 @@
                 <a:ea typeface="微软雅黑" pitchFamily="34" charset="-122"/>
                 <a:cs typeface="微软雅黑" pitchFamily="34" charset="-120"/>
               </a:rPr>
-              <a:t>留出集单独检查，未参与调参。</a:t>
-            </a:r>
-            <a:endParaRPr lang="en-US" sz="860" dirty="0"/>
-          </a:p>
-        </p:txBody>
-      </p:sp>
-      <p:sp>
-        <p:nvSpPr>
-          <p:cNvPr id="45" name="Shape 43"/>
-          <p:cNvSpPr/>
-          <p:nvPr/>
-        </p:nvSpPr>
-        <p:spPr>
-          <a:xfrm>
-            <a:off x="566928" y="5431536"/>
-            <a:ext cx="11057839" cy="566928"/>
-          </a:xfrm>
-          <a:prstGeom prst="roundRect">
-            <a:avLst>
-              <a:gd name="adj" fmla="val 8065"/>
-            </a:avLst>
-          </a:prstGeom>
-          <a:solidFill>
-            <a:srgbClr val="F6F3EE"/>
-          </a:solidFill>
-          <a:ln w="12700">
-            <a:solidFill>
-              <a:srgbClr val="EDE4D8"/>
-            </a:solidFill>
-            <a:prstDash val="solid"/>
-          </a:ln>
-        </p:spPr>
-      </p:sp>
-      <p:sp>
-        <p:nvSpPr>
-          <p:cNvPr id="46" name="Text 44"/>
-          <p:cNvSpPr/>
-          <p:nvPr/>
-        </p:nvSpPr>
-        <p:spPr>
-          <a:xfrm>
-            <a:off x="768096" y="5486400"/>
-            <a:ext cx="10655503" cy="164592"/>
-          </a:xfrm>
-          <a:prstGeom prst="rect">
-            <a:avLst/>
-          </a:prstGeom>
-          <a:noFill/>
-        </p:spPr>
-        <p:txBody>
-          <a:bodyPr wrap="square" lIns="0" tIns="0" rIns="0" bIns="0" rtlCol="0" anchor="t"/>
-          <a:lstStyle/>
-          <a:p>
-            <a:pPr marL="0" indent="0" algn="l">
-              <a:buNone/>
-            </a:pPr>
-            <a:r>
-              <a:rPr lang="en-US" sz="880" b="1" dirty="0">
-                <a:solidFill>
-                  <a:srgbClr val="A87A10"/>
-                </a:solidFill>
-                <a:latin typeface="微软雅黑" pitchFamily="34" charset="0"/>
-                <a:ea typeface="微软雅黑" pitchFamily="34" charset="-122"/>
-                <a:cs typeface="微软雅黑" pitchFamily="34" charset="-120"/>
-              </a:rPr>
-              <a:t>口径与边界（必须与上面的数字一起读）</a:t>
-            </a:r>
-            <a:endParaRPr lang="en-US" sz="880" dirty="0"/>
-          </a:p>
-        </p:txBody>
-      </p:sp>
-      <p:sp>
-        <p:nvSpPr>
-          <p:cNvPr id="47" name="Text 45"/>
-          <p:cNvSpPr/>
-          <p:nvPr/>
-        </p:nvSpPr>
-        <p:spPr>
-          <a:xfrm>
-            <a:off x="768096" y="5669280"/>
-            <a:ext cx="10655503" cy="274320"/>
-          </a:xfrm>
-          <a:prstGeom prst="rect">
-            <a:avLst/>
-          </a:prstGeom>
-          <a:noFill/>
-        </p:spPr>
-        <p:txBody>
-          <a:bodyPr wrap="square" lIns="0" tIns="0" rIns="0" bIns="0" rtlCol="0" anchor="t"/>
-          <a:lstStyle/>
+              <a:t>人工：逐项检查阈值边界、标签权限和未知值处理。</a:t>
+            </a:r>
+            <a:endParaRPr lang="zh-CN" altLang="en-US" sz="860" dirty="0">
+              <a:solidFill>
+                <a:srgbClr val="5B4F43"/>
+              </a:solidFill>
+              <a:latin typeface="微软雅黑" pitchFamily="34" charset="0"/>
+              <a:ea typeface="微软雅黑" pitchFamily="34" charset="-122"/>
+              <a:cs typeface="微软雅黑" pitchFamily="34" charset="-120"/>
+            </a:endParaRPr>
+          </a:p>
           <a:p>
             <a:pPr marL="0" indent="0" algn="l">
               <a:lnSpc>
@@ -17210,7 +17964,7 @@
               <a:buNone/>
             </a:pPr>
             <a:r>
-              <a:rPr lang="en-US" sz="840" dirty="0">
+              <a:rPr lang="en-US" altLang="zh-CN" sz="860" dirty="0">
                 <a:solidFill>
                   <a:srgbClr val="5B4F43"/>
                 </a:solidFill>
@@ -17218,47 +17972,38 @@
                 <a:ea typeface="微软雅黑" pitchFamily="34" charset="-122"/>
                 <a:cs typeface="微软雅黑" pitchFamily="34" charset="-120"/>
               </a:rPr>
-              <a:t>① 人工基线未做对照测量，故不给「人工 vs AI」的提升百分比。② L2 为分层抽样（P2 抽 500 / 1,994），非全量。③ 稳定性复跑 NOT_MEASURED（计划 300 次，实际 42 次），故不给近似值。④ L3 Java 执行本轮 NOT_APPLICABLE。</a:t>
-            </a:r>
-            <a:endParaRPr lang="en-US" sz="840" dirty="0"/>
-          </a:p>
-        </p:txBody>
-      </p:sp>
-      <p:sp>
-        <p:nvSpPr>
-          <p:cNvPr id="48" name="Text 46"/>
-          <p:cNvSpPr/>
-          <p:nvPr/>
-        </p:nvSpPr>
-        <p:spPr>
-          <a:xfrm>
-            <a:off x="566928" y="6345936"/>
-            <a:ext cx="10143439" cy="310896"/>
-          </a:xfrm>
-          <a:prstGeom prst="rect">
-            <a:avLst/>
-          </a:prstGeom>
-          <a:noFill/>
-        </p:spPr>
-        <p:txBody>
-          <a:bodyPr wrap="square" lIns="0" tIns="0" rIns="0" bIns="0" rtlCol="0" anchor="t"/>
-          <a:lstStyle/>
-          <a:p>
-            <a:pPr marL="0" indent="0" algn="l">
-              <a:buNone/>
-            </a:pPr>
-            <a:r>
-              <a:rPr lang="en-US" sz="850" dirty="0">
-                <a:solidFill>
-                  <a:srgbClr val="96897B"/>
-                </a:solidFill>
-                <a:latin typeface="微软雅黑" pitchFamily="34" charset="0"/>
-                <a:ea typeface="微软雅黑" pitchFamily="34" charset="-122"/>
-                <a:cs typeface="微软雅黑" pitchFamily="34" charset="-120"/>
-              </a:rPr>
-              <a:t>来源：tagpilot-eval/reports/p3-acceptance-v1/（A/B/C/D 对照与 HOLDOUT）；reports/p2-acceptance-v1/REPORT.md（L2 抽样）。</a:t>
-            </a:r>
-            <a:endParaRPr lang="en-US" sz="850" dirty="0"/>
+              <a:t>AI </a:t>
+            </a:r>
+            <a:r>
+              <a:rPr lang="zh-CN" altLang="en-US" sz="860" dirty="0">
+                <a:solidFill>
+                  <a:srgbClr val="5B4F43"/>
+                </a:solidFill>
+                <a:latin typeface="微软雅黑" pitchFamily="34" charset="0"/>
+                <a:ea typeface="微软雅黑" pitchFamily="34" charset="-122"/>
+                <a:cs typeface="微软雅黑" pitchFamily="34" charset="-120"/>
+              </a:rPr>
+              <a:t>辅助：自动拦截不合规条件</a:t>
+            </a:r>
+            <a:r>
+              <a:rPr lang="en-US" altLang="zh-CN" sz="860" dirty="0">
+                <a:solidFill>
+                  <a:srgbClr val="5B4F43"/>
+                </a:solidFill>
+                <a:latin typeface="微软雅黑" pitchFamily="34" charset="0"/>
+                <a:ea typeface="微软雅黑" pitchFamily="34" charset="-122"/>
+                <a:cs typeface="微软雅黑" pitchFamily="34" charset="-120"/>
+              </a:rPr>
+              <a:t>。</a:t>
+            </a:r>
+            <a:endParaRPr lang="en-US" altLang="zh-CN" sz="860" dirty="0">
+              <a:solidFill>
+                <a:srgbClr val="5B4F43"/>
+              </a:solidFill>
+              <a:latin typeface="微软雅黑" pitchFamily="34" charset="0"/>
+              <a:ea typeface="微软雅黑" pitchFamily="34" charset="-122"/>
+              <a:cs typeface="微软雅黑" pitchFamily="34" charset="-120"/>
+            </a:endParaRPr>
           </a:p>
         </p:txBody>
       </p:sp>
@@ -18697,30 +19442,6 @@
           </a:effectLst>
         </p:spPr>
       </p:sp>
-      <p:pic>
-        <p:nvPicPr>
-          <p:cNvPr id="40" name="Image 0" descr=".pptx-build/assets/shot-workbench.png"/>
-          <p:cNvPicPr>
-            <a:picLocks noChangeAspect="1"/>
-          </p:cNvPicPr>
-          <p:nvPr/>
-        </p:nvPicPr>
-        <p:blipFill>
-          <a:blip r:embed="rId1"/>
-          <a:stretch>
-            <a:fillRect/>
-          </a:stretch>
-        </p:blipFill>
-        <p:spPr>
-          <a:xfrm>
-            <a:off x="676656" y="2615184"/>
-            <a:ext cx="5218024" cy="2697480"/>
-          </a:xfrm>
-          <a:prstGeom prst="rect">
-            <a:avLst/>
-          </a:prstGeom>
-        </p:spPr>
-      </p:pic>
       <p:sp>
         <p:nvSpPr>
           <p:cNvPr id="41" name="Text 38"/>
@@ -18843,6 +19564,174 @@
           <p:nvPr/>
         </p:nvPicPr>
         <p:blipFill>
+          <a:blip r:embed="rId1"/>
+          <a:stretch>
+            <a:fillRect/>
+          </a:stretch>
+        </p:blipFill>
+        <p:spPr>
+          <a:xfrm>
+            <a:off x="6297016" y="2615184"/>
+            <a:ext cx="5218024" cy="2697480"/>
+          </a:xfrm>
+          <a:prstGeom prst="rect">
+            <a:avLst/>
+          </a:prstGeom>
+        </p:spPr>
+      </p:pic>
+      <p:sp>
+        <p:nvSpPr>
+          <p:cNvPr id="45" name="Text 41"/>
+          <p:cNvSpPr/>
+          <p:nvPr/>
+        </p:nvSpPr>
+        <p:spPr>
+          <a:xfrm>
+            <a:off x="6370168" y="5413248"/>
+            <a:ext cx="5071720" cy="219456"/>
+          </a:xfrm>
+          <a:prstGeom prst="rect">
+            <a:avLst/>
+          </a:prstGeom>
+          <a:noFill/>
+        </p:spPr>
+        <p:txBody>
+          <a:bodyPr wrap="square" lIns="0" tIns="0" rIns="0" bIns="0" rtlCol="0" anchor="t"/>
+          <a:lstStyle/>
+          <a:p>
+            <a:pPr marL="0" indent="0" algn="l">
+              <a:buNone/>
+            </a:pPr>
+            <a:r>
+              <a:rPr lang="en-US" sz="1100" b="1" dirty="0">
+                <a:solidFill>
+                  <a:srgbClr val="2A1C0E"/>
+                </a:solidFill>
+                <a:latin typeface="微软雅黑" pitchFamily="34" charset="0"/>
+                <a:ea typeface="微软雅黑" pitchFamily="34" charset="-122"/>
+                <a:cs typeface="微软雅黑" pitchFamily="34" charset="-120"/>
+              </a:rPr>
+              <a:t>② 洞察报告</a:t>
+            </a:r>
+            <a:endParaRPr lang="en-US" sz="1100" dirty="0"/>
+          </a:p>
+        </p:txBody>
+      </p:sp>
+      <p:sp>
+        <p:nvSpPr>
+          <p:cNvPr id="46" name="Text 42"/>
+          <p:cNvSpPr/>
+          <p:nvPr/>
+        </p:nvSpPr>
+        <p:spPr>
+          <a:xfrm>
+            <a:off x="6370168" y="5650992"/>
+            <a:ext cx="5071720" cy="310896"/>
+          </a:xfrm>
+          <a:prstGeom prst="rect">
+            <a:avLst/>
+          </a:prstGeom>
+          <a:noFill/>
+        </p:spPr>
+        <p:txBody>
+          <a:bodyPr wrap="square" lIns="0" tIns="0" rIns="0" bIns="0" rtlCol="0" anchor="t"/>
+          <a:lstStyle/>
+          <a:p>
+            <a:pPr marL="0" indent="0" algn="l">
+              <a:lnSpc>
+                <a:spcPts val="1180"/>
+              </a:lnSpc>
+              <a:buNone/>
+            </a:pPr>
+            <a:r>
+              <a:rPr lang="en-US" sz="860" dirty="0">
+                <a:solidFill>
+                  <a:srgbClr val="5B4F43"/>
+                </a:solidFill>
+                <a:latin typeface="微软雅黑" pitchFamily="34" charset="0"/>
+                <a:ea typeface="微软雅黑" pitchFamily="34" charset="-122"/>
+                <a:cs typeface="微软雅黑" pitchFamily="34" charset="-120"/>
+              </a:rPr>
+              <a:t>五段结构（事实 / 对比 / 诊断·规则 / 行动 / 证据与边界）+ KPI 与图表，逐图可导出。</a:t>
+            </a:r>
+            <a:endParaRPr lang="en-US" sz="860" dirty="0"/>
+          </a:p>
+        </p:txBody>
+      </p:sp>
+      <p:sp>
+        <p:nvSpPr>
+          <p:cNvPr id="47" name="Text 43"/>
+          <p:cNvSpPr/>
+          <p:nvPr/>
+        </p:nvSpPr>
+        <p:spPr>
+          <a:xfrm>
+            <a:off x="566928" y="6345936"/>
+            <a:ext cx="10143439" cy="310896"/>
+          </a:xfrm>
+          <a:prstGeom prst="rect">
+            <a:avLst/>
+          </a:prstGeom>
+          <a:noFill/>
+        </p:spPr>
+        <p:txBody>
+          <a:bodyPr wrap="square" lIns="0" tIns="0" rIns="0" bIns="0" rtlCol="0" anchor="t"/>
+          <a:lstStyle/>
+          <a:p>
+            <a:pPr marL="0" indent="0" algn="l">
+              <a:buNone/>
+            </a:pPr>
+            <a:endParaRPr lang="en-US" sz="850" dirty="0"/>
+          </a:p>
+        </p:txBody>
+      </p:sp>
+      <p:sp>
+        <p:nvSpPr>
+          <p:cNvPr id="48" name="Text 44"/>
+          <p:cNvSpPr/>
+          <p:nvPr/>
+        </p:nvSpPr>
+        <p:spPr>
+          <a:xfrm>
+            <a:off x="10801807" y="6345936"/>
+            <a:ext cx="822960" cy="274320"/>
+          </a:xfrm>
+          <a:prstGeom prst="rect">
+            <a:avLst/>
+          </a:prstGeom>
+          <a:noFill/>
+        </p:spPr>
+        <p:txBody>
+          <a:bodyPr wrap="square" lIns="0" tIns="0" rIns="0" bIns="0" rtlCol="0" anchor="t"/>
+          <a:lstStyle/>
+          <a:p>
+            <a:pPr marL="0" indent="0" algn="r">
+              <a:buNone/>
+            </a:pPr>
+            <a:r>
+              <a:rPr lang="en-US" sz="900" dirty="0">
+                <a:solidFill>
+                  <a:srgbClr val="96897B"/>
+                </a:solidFill>
+                <a:latin typeface="Cambria" pitchFamily="34" charset="0"/>
+                <a:ea typeface="Cambria" pitchFamily="34" charset="-122"/>
+                <a:cs typeface="Cambria" pitchFamily="34" charset="-120"/>
+              </a:rPr>
+              <a:t>09</a:t>
+            </a:r>
+            <a:endParaRPr lang="en-US" sz="900" dirty="0"/>
+          </a:p>
+        </p:txBody>
+      </p:sp>
+      <p:pic>
+        <p:nvPicPr>
+          <p:cNvPr id="49" name="图片 48"/>
+          <p:cNvPicPr>
+            <a:picLocks noChangeAspect="1"/>
+          </p:cNvPicPr>
+          <p:nvPr/>
+        </p:nvPicPr>
+        <p:blipFill>
           <a:blip r:embed="rId2"/>
           <a:stretch>
             <a:fillRect/>
@@ -18850,169 +19739,14 @@
         </p:blipFill>
         <p:spPr>
           <a:xfrm>
-            <a:off x="6297016" y="2615184"/>
-            <a:ext cx="5218024" cy="2697480"/>
+            <a:off x="632460" y="2613660"/>
+            <a:ext cx="5280660" cy="2699385"/>
           </a:xfrm>
           <a:prstGeom prst="rect">
             <a:avLst/>
           </a:prstGeom>
         </p:spPr>
       </p:pic>
-      <p:sp>
-        <p:nvSpPr>
-          <p:cNvPr id="45" name="Text 41"/>
-          <p:cNvSpPr/>
-          <p:nvPr/>
-        </p:nvSpPr>
-        <p:spPr>
-          <a:xfrm>
-            <a:off x="6370168" y="5413248"/>
-            <a:ext cx="5071720" cy="219456"/>
-          </a:xfrm>
-          <a:prstGeom prst="rect">
-            <a:avLst/>
-          </a:prstGeom>
-          <a:noFill/>
-        </p:spPr>
-        <p:txBody>
-          <a:bodyPr wrap="square" lIns="0" tIns="0" rIns="0" bIns="0" rtlCol="0" anchor="t"/>
-          <a:lstStyle/>
-          <a:p>
-            <a:pPr marL="0" indent="0" algn="l">
-              <a:buNone/>
-            </a:pPr>
-            <a:r>
-              <a:rPr lang="en-US" sz="1100" b="1" dirty="0">
-                <a:solidFill>
-                  <a:srgbClr val="2A1C0E"/>
-                </a:solidFill>
-                <a:latin typeface="微软雅黑" pitchFamily="34" charset="0"/>
-                <a:ea typeface="微软雅黑" pitchFamily="34" charset="-122"/>
-                <a:cs typeface="微软雅黑" pitchFamily="34" charset="-120"/>
-              </a:rPr>
-              <a:t>② 洞察报告</a:t>
-            </a:r>
-            <a:endParaRPr lang="en-US" sz="1100" dirty="0"/>
-          </a:p>
-        </p:txBody>
-      </p:sp>
-      <p:sp>
-        <p:nvSpPr>
-          <p:cNvPr id="46" name="Text 42"/>
-          <p:cNvSpPr/>
-          <p:nvPr/>
-        </p:nvSpPr>
-        <p:spPr>
-          <a:xfrm>
-            <a:off x="6370168" y="5650992"/>
-            <a:ext cx="5071720" cy="310896"/>
-          </a:xfrm>
-          <a:prstGeom prst="rect">
-            <a:avLst/>
-          </a:prstGeom>
-          <a:noFill/>
-        </p:spPr>
-        <p:txBody>
-          <a:bodyPr wrap="square" lIns="0" tIns="0" rIns="0" bIns="0" rtlCol="0" anchor="t"/>
-          <a:lstStyle/>
-          <a:p>
-            <a:pPr marL="0" indent="0" algn="l">
-              <a:lnSpc>
-                <a:spcPts val="1180"/>
-              </a:lnSpc>
-              <a:buNone/>
-            </a:pPr>
-            <a:r>
-              <a:rPr lang="en-US" sz="860" dirty="0">
-                <a:solidFill>
-                  <a:srgbClr val="5B4F43"/>
-                </a:solidFill>
-                <a:latin typeface="微软雅黑" pitchFamily="34" charset="0"/>
-                <a:ea typeface="微软雅黑" pitchFamily="34" charset="-122"/>
-                <a:cs typeface="微软雅黑" pitchFamily="34" charset="-120"/>
-              </a:rPr>
-              <a:t>五段结构（事实 / 对比 / 诊断·规则 / 行动 / 证据与边界）+ KPI 与图表，逐图可导出。</a:t>
-            </a:r>
-            <a:endParaRPr lang="en-US" sz="860" dirty="0"/>
-          </a:p>
-        </p:txBody>
-      </p:sp>
-      <p:sp>
-        <p:nvSpPr>
-          <p:cNvPr id="47" name="Text 43"/>
-          <p:cNvSpPr/>
-          <p:nvPr/>
-        </p:nvSpPr>
-        <p:spPr>
-          <a:xfrm>
-            <a:off x="566928" y="6345936"/>
-            <a:ext cx="10143439" cy="310896"/>
-          </a:xfrm>
-          <a:prstGeom prst="rect">
-            <a:avLst/>
-          </a:prstGeom>
-          <a:noFill/>
-        </p:spPr>
-        <p:txBody>
-          <a:bodyPr wrap="square" lIns="0" tIns="0" rIns="0" bIns="0" rtlCol="0" anchor="t"/>
-          <a:lstStyle/>
-          <a:p>
-            <a:pPr marL="0" indent="0" algn="l">
-              <a:buNone/>
-            </a:pPr>
-            <a:r>
-              <a:rPr lang="en-US" sz="850" dirty="0">
-                <a:solidFill>
-                  <a:srgbClr val="96897B"/>
-                </a:solidFill>
-                <a:latin typeface="微软雅黑" pitchFamily="34" charset="0"/>
-                <a:ea typeface="微软雅黑" pitchFamily="34" charset="-122"/>
-                <a:cs typeface="微软雅黑" pitchFamily="34" charset="-120"/>
-              </a:rPr>
-              <a:t>截图来源：本地运行的工作台实际界面（.impeccable/review/ 下的桌面端截图），非渲染稿；截图内数据由产品界面自身标注为「合成聚合数据预览」，已声明背景与数据日期。</a:t>
-            </a:r>
-            <a:endParaRPr lang="en-US" sz="850" dirty="0"/>
-          </a:p>
-        </p:txBody>
-      </p:sp>
-      <p:sp>
-        <p:nvSpPr>
-          <p:cNvPr id="48" name="Text 44"/>
-          <p:cNvSpPr/>
-          <p:nvPr/>
-        </p:nvSpPr>
-        <p:spPr>
-          <a:xfrm>
-            <a:off x="10801807" y="6345936"/>
-            <a:ext cx="822960" cy="274320"/>
-          </a:xfrm>
-          <a:prstGeom prst="rect">
-            <a:avLst/>
-          </a:prstGeom>
-          <a:noFill/>
-        </p:spPr>
-        <p:txBody>
-          <a:bodyPr wrap="square" lIns="0" tIns="0" rIns="0" bIns="0" rtlCol="0" anchor="t"/>
-          <a:lstStyle/>
-          <a:p>
-            <a:pPr marL="0" indent="0" algn="r">
-              <a:buNone/>
-            </a:pPr>
-            <a:r>
-              <a:rPr lang="en-US" sz="900" dirty="0">
-                <a:solidFill>
-                  <a:srgbClr val="96897B"/>
-                </a:solidFill>
-                <a:latin typeface="Cambria" pitchFamily="34" charset="0"/>
-                <a:ea typeface="Cambria" pitchFamily="34" charset="-122"/>
-                <a:cs typeface="Cambria" pitchFamily="34" charset="-120"/>
-              </a:rPr>
-              <a:t>09</a:t>
-            </a:r>
-            <a:endParaRPr lang="en-US" sz="900" dirty="0"/>
-          </a:p>
-        </p:txBody>
-      </p:sp>
     </p:spTree>
   </p:cSld>
   <p:clrMapOvr>

</xml_diff>